<commit_message>
Split the GPS and SDR
</commit_message>
<xml_diff>
--- a/4 ACT AW - GPS.pptx
+++ b/4 ACT AW - GPS.pptx
@@ -5,24 +5,22 @@
     <p:sldMasterId id="2147483702" r:id="rId5"/>
   </p:sldMasterIdLst>
   <p:notesMasterIdLst>
-    <p:notesMasterId r:id="rId16"/>
+    <p:notesMasterId r:id="rId14"/>
   </p:notesMasterIdLst>
   <p:sldIdLst>
     <p:sldId id="757" r:id="rId6"/>
     <p:sldId id="368" r:id="rId7"/>
     <p:sldId id="369" r:id="rId8"/>
-    <p:sldId id="370" r:id="rId9"/>
-    <p:sldId id="371" r:id="rId10"/>
-    <p:sldId id="372" r:id="rId11"/>
-    <p:sldId id="373" r:id="rId12"/>
-    <p:sldId id="374" r:id="rId13"/>
-    <p:sldId id="755" r:id="rId14"/>
-    <p:sldId id="756" r:id="rId15"/>
+    <p:sldId id="759" r:id="rId9"/>
+    <p:sldId id="758" r:id="rId10"/>
+    <p:sldId id="760" r:id="rId11"/>
+    <p:sldId id="755" r:id="rId12"/>
+    <p:sldId id="756" r:id="rId13"/>
   </p:sldIdLst>
   <p:sldSz cx="12192000" cy="6858000"/>
   <p:notesSz cx="6858000" cy="9144000"/>
   <p:custDataLst>
-    <p:tags r:id="rId17"/>
+    <p:tags r:id="rId15"/>
   </p:custDataLst>
   <p:defaultTextStyle>
     <a:defPPr>
@@ -128,14 +126,12 @@
             <p14:sldId id="368"/>
           </p14:sldIdLst>
         </p14:section>
-        <p14:section name="GPS Spoofing" id="{0232622A-D73C-488C-9472-06D36E450D2A}">
+        <p14:section name="GPS Viewing" id="{0232622A-D73C-488C-9472-06D36E450D2A}">
           <p14:sldIdLst>
             <p14:sldId id="369"/>
-            <p14:sldId id="370"/>
-            <p14:sldId id="371"/>
-            <p14:sldId id="372"/>
-            <p14:sldId id="373"/>
-            <p14:sldId id="374"/>
+            <p14:sldId id="759"/>
+            <p14:sldId id="758"/>
+            <p14:sldId id="760"/>
           </p14:sldIdLst>
         </p14:section>
         <p14:section name="Appendix" id="{9767354D-BE9E-4F2F-8046-9D9ABD2D4757}">
@@ -5054,7 +5050,7 @@
           <a:p>
             <a:fld id="{2FC2648E-2733-4EC8-BEDA-1577DE2D3D01}" type="datetimeFigureOut">
               <a:rPr lang="en-US" smtClean="0"/>
-              <a:t>9/4/2026</a:t>
+              <a:t>10/16/2026</a:t>
             </a:fld>
             <a:endParaRPr lang="en-US"/>
           </a:p>
@@ -5540,7 +5536,7 @@
             <a:fld id="{9DE42932-4F59-45AE-B54E-8D561FACD657}" type="slidenum">
               <a:rPr altLang="en-US" b="0"/>
               <a:pPr eaLnBrk="1" hangingPunct="1"/>
-              <a:t>9</a:t>
+              <a:t>7</a:t>
             </a:fld>
             <a:endParaRPr lang="en-US" altLang="en-US" b="0" dirty="0"/>
           </a:p>
@@ -5778,7 +5774,7 @@
             <a:fld id="{9DE42932-4F59-45AE-B54E-8D561FACD657}" type="slidenum">
               <a:rPr altLang="en-US" b="0"/>
               <a:pPr eaLnBrk="1" hangingPunct="1"/>
-              <a:t>10</a:t>
+              <a:t>8</a:t>
             </a:fld>
             <a:endParaRPr lang="en-US" altLang="en-US" b="0" dirty="0"/>
           </a:p>
@@ -5837,7 +5833,7 @@
           <a:p>
             <a:fld id="{8CF61943-3342-4554-8403-118C8C1529D5}" type="datetimeFigureOut">
               <a:rPr lang="en-US" smtClean="0"/>
-              <a:t>9/4/2026</a:t>
+              <a:t>10/16/2026</a:t>
             </a:fld>
             <a:endParaRPr lang="en-US"/>
           </a:p>
@@ -6200,7 +6196,7 @@
           <a:p>
             <a:fld id="{8CF61943-3342-4554-8403-118C8C1529D5}" type="datetimeFigureOut">
               <a:rPr lang="en-US" smtClean="0"/>
-              <a:t>9/4/2026</a:t>
+              <a:t>10/16/2026</a:t>
             </a:fld>
             <a:endParaRPr lang="en-US"/>
           </a:p>
@@ -6734,253 +6730,6 @@
 </p:sld>
 </file>
 
-<file path=ppt/slides/slide10.xml><?xml version="1.0" encoding="utf-8"?>
-<p:sld xmlns:a="http://schemas.openxmlformats.org/drawingml/2006/main" xmlns:r="http://schemas.openxmlformats.org/officeDocument/2006/relationships" xmlns:p="http://schemas.openxmlformats.org/presentationml/2006/main">
-  <p:cSld>
-    <p:spTree>
-      <p:nvGrpSpPr>
-        <p:cNvPr id="1" name=""/>
-        <p:cNvGrpSpPr/>
-        <p:nvPr/>
-      </p:nvGrpSpPr>
-      <p:grpSpPr>
-        <a:xfrm>
-          <a:off x="0" y="0"/>
-          <a:ext cx="0" cy="0"/>
-          <a:chOff x="0" y="0"/>
-          <a:chExt cx="0" cy="0"/>
-        </a:xfrm>
-      </p:grpSpPr>
-      <p:sp>
-        <p:nvSpPr>
-          <p:cNvPr id="10245" name="Title 1"/>
-          <p:cNvSpPr>
-            <a:spLocks noGrp="1"/>
-          </p:cNvSpPr>
-          <p:nvPr>
-            <p:ph type="title"/>
-          </p:nvPr>
-        </p:nvSpPr>
-        <p:spPr>
-          <a:xfrm>
-            <a:off x="1981200" y="274638"/>
-            <a:ext cx="8229600" cy="698305"/>
-          </a:xfrm>
-        </p:spPr>
-        <p:txBody>
-          <a:bodyPr>
-            <a:normAutofit fontScale="90000"/>
-          </a:bodyPr>
-          <a:lstStyle/>
-          <a:p>
-            <a:r>
-              <a:rPr lang="en-US" dirty="0"/>
-              <a:t>GPS Security</a:t>
-            </a:r>
-          </a:p>
-        </p:txBody>
-      </p:sp>
-      <p:sp>
-        <p:nvSpPr>
-          <p:cNvPr id="17411" name="Content Placeholder 10"/>
-          <p:cNvSpPr>
-            <a:spLocks noGrp="1"/>
-          </p:cNvSpPr>
-          <p:nvPr>
-            <p:ph idx="1"/>
-          </p:nvPr>
-        </p:nvSpPr>
-        <p:spPr>
-          <a:xfrm>
-            <a:off x="1792288" y="972943"/>
-            <a:ext cx="8699500" cy="5451671"/>
-          </a:xfrm>
-        </p:spPr>
-        <p:txBody>
-          <a:bodyPr>
-            <a:normAutofit/>
-          </a:bodyPr>
-          <a:lstStyle/>
-          <a:p>
-            <a:r>
-              <a:rPr lang="en-US" sz="1600" dirty="0"/>
-              <a:t>Interference</a:t>
-            </a:r>
-          </a:p>
-          <a:p>
-            <a:pPr lvl="1"/>
-            <a:r>
-              <a:rPr lang="en-US" sz="1200" dirty="0"/>
-              <a:t>Typically environmental</a:t>
-            </a:r>
-          </a:p>
-          <a:p>
-            <a:pPr lvl="1"/>
-            <a:r>
-              <a:rPr lang="en-US" sz="1200" dirty="0">
-                <a:hlinkClick r:id="rId3"/>
-              </a:rPr>
-              <a:t>https://www.gps.gov/spectrum/</a:t>
-            </a:r>
-            <a:endParaRPr lang="en-US" sz="1200" dirty="0"/>
-          </a:p>
-          <a:p>
-            <a:pPr lvl="1"/>
-            <a:r>
-              <a:rPr lang="en-US" sz="1200" dirty="0">
-                <a:hlinkClick r:id="rId4"/>
-              </a:rPr>
-              <a:t>https://www.gps.gov/news/2012/03/solarstorm/</a:t>
-            </a:r>
-            <a:endParaRPr lang="en-US" sz="1200" dirty="0"/>
-          </a:p>
-          <a:p>
-            <a:r>
-              <a:rPr lang="en-US" sz="1600" dirty="0"/>
-              <a:t>Jamming</a:t>
-            </a:r>
-          </a:p>
-          <a:p>
-            <a:pPr lvl="1"/>
-            <a:r>
-              <a:rPr lang="en-US" sz="1200" dirty="0"/>
-              <a:t>Is illegal</a:t>
-            </a:r>
-          </a:p>
-          <a:p>
-            <a:pPr lvl="1"/>
-            <a:r>
-              <a:rPr lang="en-US" sz="1200" dirty="0">
-                <a:hlinkClick r:id="rId5"/>
-              </a:rPr>
-              <a:t>https://www.gps.gov/spectrum/jamming/</a:t>
-            </a:r>
-          </a:p>
-          <a:p>
-            <a:pPr lvl="1"/>
-            <a:r>
-              <a:rPr lang="en-US" sz="1200" dirty="0">
-                <a:hlinkClick r:id="rId5"/>
-              </a:rPr>
-              <a:t>http://gpsworld.com/tag/gps-jamming/</a:t>
-            </a:r>
-          </a:p>
-          <a:p>
-            <a:pPr lvl="1"/>
-            <a:r>
-              <a:rPr lang="en-US" sz="1200" dirty="0">
-                <a:hlinkClick r:id="rId5"/>
-              </a:rPr>
-              <a:t>https://www.thesignaljammer.com/pages/How-GPS-Jammers-Work.html</a:t>
-            </a:r>
-            <a:endParaRPr lang="en-US" sz="1200" dirty="0"/>
-          </a:p>
-          <a:p>
-            <a:pPr lvl="1"/>
-            <a:r>
-              <a:rPr lang="en-US" sz="1200" dirty="0">
-                <a:hlinkClick r:id="rId6"/>
-              </a:rPr>
-              <a:t>https://gizmodo.com/jamming-gps-signals-is-illegal-dangerous-cheap-and-e-1796778955</a:t>
-            </a:r>
-            <a:endParaRPr lang="en-US" sz="1200" dirty="0"/>
-          </a:p>
-          <a:p>
-            <a:r>
-              <a:rPr lang="en-US" sz="1600" dirty="0"/>
-              <a:t>Spoofing (broadcasting false information)</a:t>
-            </a:r>
-          </a:p>
-          <a:p>
-            <a:pPr lvl="1"/>
-            <a:r>
-              <a:rPr lang="en-US" sz="1200" dirty="0"/>
-              <a:t>Is also illegal</a:t>
-            </a:r>
-            <a:endParaRPr lang="en-US" sz="1200" dirty="0">
-              <a:hlinkClick r:id="rId7"/>
-            </a:endParaRPr>
-          </a:p>
-          <a:p>
-            <a:pPr lvl="1"/>
-            <a:r>
-              <a:rPr lang="en-US" sz="1200" dirty="0">
-                <a:hlinkClick r:id="rId7"/>
-              </a:rPr>
-              <a:t>https://www.gps.gov/multimedia/presentations/2016/04/APEC/alexander-2.pdf</a:t>
-            </a:r>
-          </a:p>
-          <a:p>
-            <a:pPr lvl="1"/>
-            <a:r>
-              <a:rPr lang="en-US" sz="1200" dirty="0">
-                <a:hlinkClick r:id="rId7"/>
-              </a:rPr>
-              <a:t>https://en.wikipedia.org/wiki/Spoofing_attack#GPS_spoofing</a:t>
-            </a:r>
-          </a:p>
-          <a:p>
-            <a:pPr lvl="1"/>
-            <a:r>
-              <a:rPr lang="en-US" sz="1200" dirty="0">
-                <a:hlinkClick r:id="rId7"/>
-              </a:rPr>
-              <a:t>https://www.schneier.com/blog/archives/2017/09/gps_spoofing_at.html</a:t>
-            </a:r>
-          </a:p>
-          <a:p>
-            <a:pPr lvl="1"/>
-            <a:r>
-              <a:rPr lang="en-US" sz="1200" dirty="0">
-                <a:hlinkClick r:id="rId7"/>
-              </a:rPr>
-              <a:t>https://www.spirent.com/Blogs/Positioning/2015/September/GPS_Spoofing_Is_a_Real_Threat</a:t>
-            </a:r>
-          </a:p>
-          <a:p>
-            <a:pPr lvl="1"/>
-            <a:r>
-              <a:rPr lang="en-US" sz="1200" dirty="0">
-                <a:hlinkClick r:id="rId7"/>
-              </a:rPr>
-              <a:t>https://www.spirent.com/Blogs/Positioning/2017/September/DEFCON-25</a:t>
-            </a:r>
-          </a:p>
-          <a:p>
-            <a:pPr lvl="1"/>
-            <a:r>
-              <a:rPr lang="en-US" sz="1200" dirty="0">
-                <a:hlinkClick r:id="rId7"/>
-              </a:rPr>
-              <a:t>https://www.digitaltrends.com/mobile/gps-spoofing/</a:t>
-            </a:r>
-            <a:endParaRPr lang="en-US" sz="1200" dirty="0"/>
-          </a:p>
-          <a:p>
-            <a:pPr lvl="1"/>
-            <a:endParaRPr lang="en-US" sz="1200" dirty="0"/>
-          </a:p>
-          <a:p>
-            <a:endParaRPr lang="en-US" sz="1400" dirty="0"/>
-          </a:p>
-        </p:txBody>
-      </p:sp>
-    </p:spTree>
-    <p:extLst>
-      <p:ext uri="{BB962C8B-B14F-4D97-AF65-F5344CB8AC3E}">
-        <p14:creationId xmlns:p14="http://schemas.microsoft.com/office/powerpoint/2010/main" val="2741046450"/>
-      </p:ext>
-    </p:extLst>
-  </p:cSld>
-  <p:clrMapOvr>
-    <a:masterClrMapping/>
-  </p:clrMapOvr>
-  <p:transition>
-    <p:fade/>
-  </p:transition>
-</p:sld>
-</file>
-
 <file path=ppt/slides/slide2.xml><?xml version="1.0" encoding="utf-8"?>
 <p:sld xmlns:a="http://schemas.openxmlformats.org/drawingml/2006/main" xmlns:r="http://schemas.openxmlformats.org/officeDocument/2006/relationships" xmlns:p="http://schemas.openxmlformats.org/presentationml/2006/main" showMasterSp="0">
   <p:cSld>
@@ -7339,30 +7088,6 @@
             </a:pPr>
             <a:r>
               <a:rPr sz="5600" dirty="0"/>
-              <a:t>Live</a:t>
-            </a:r>
-            <a:r>
-              <a:rPr sz="5600" spc="-133" dirty="0"/>
-              <a:t> </a:t>
-            </a:r>
-            <a:r>
-              <a:rPr sz="5600" dirty="0"/>
-              <a:t>Spooﬁng</a:t>
-            </a:r>
-            <a:r>
-              <a:rPr sz="5600" spc="-120" dirty="0"/>
-              <a:t> </a:t>
-            </a:r>
-            <a:r>
-              <a:rPr sz="5600" dirty="0"/>
-              <a:t>of</a:t>
-            </a:r>
-            <a:r>
-              <a:rPr sz="5600" spc="-120" dirty="0"/>
-              <a:t> </a:t>
-            </a:r>
-            <a:r>
-              <a:rPr sz="5600" dirty="0"/>
               <a:t>GPS</a:t>
             </a:r>
             <a:r>
@@ -7524,8 +7249,8 @@
         </p:nvSpPr>
         <p:spPr>
           <a:xfrm>
-            <a:off x="0" y="625475"/>
-            <a:ext cx="7534275" cy="1125538"/>
+            <a:off x="0" y="-262302"/>
+            <a:ext cx="11558016" cy="2901093"/>
           </a:xfrm>
           <a:prstGeom prst="rect">
             <a:avLst/>
@@ -7551,415 +7276,76 @@
               <a:t> </a:t>
             </a:r>
             <a:r>
-              <a:rPr sz="3600" dirty="0"/>
-              <a:t>Spooﬁng</a:t>
+              <a:rPr lang="en-US" sz="3600" dirty="0"/>
+              <a:t>Installation</a:t>
+            </a:r>
+            <a:br>
+              <a:rPr lang="en-US" sz="3600" dirty="0"/>
+            </a:br>
+            <a:br>
+              <a:rPr lang="en-US" sz="3600" dirty="0"/>
+            </a:br>
+            <a:r>
+              <a:rPr lang="en-US" sz="3600" dirty="0"/>
+              <a:t>Install U-Center2 from </a:t>
             </a:r>
             <a:r>
-              <a:rPr sz="3600" spc="-33" dirty="0"/>
-              <a:t> </a:t>
+              <a:rPr lang="en-US" sz="3600" dirty="0">
+                <a:hlinkClick r:id="rId3"/>
+              </a:rPr>
+              <a:t>https://www.u-blox.com/en/u-center-2</a:t>
             </a:r>
+            <a:br>
+              <a:rPr lang="en-US" sz="3600" dirty="0"/>
+            </a:br>
             <a:r>
-              <a:rPr sz="3600" dirty="0"/>
-              <a:t>–</a:t>
+              <a:rPr lang="en-US" sz="3200" dirty="0"/>
+              <a:t>May need to register as a user</a:t>
             </a:r>
+            <a:br>
+              <a:rPr lang="en-US" sz="3200" dirty="0"/>
+            </a:br>
             <a:r>
-              <a:rPr sz="3600" spc="-13" dirty="0"/>
-              <a:t> </a:t>
+              <a:rPr lang="en-US" sz="3200" dirty="0"/>
+              <a:t>Add COM# serial port as a source</a:t>
             </a:r>
-            <a:r>
-              <a:rPr sz="3600" dirty="0">
-                <a:solidFill>
-                  <a:srgbClr val="212D73"/>
-                </a:solidFill>
-              </a:rPr>
-              <a:t>Step</a:t>
-            </a:r>
-            <a:r>
-              <a:rPr sz="3600" spc="-33" dirty="0">
-                <a:solidFill>
-                  <a:srgbClr val="212D73"/>
-                </a:solidFill>
-              </a:rPr>
-              <a:t> </a:t>
-            </a:r>
-            <a:r>
-              <a:rPr sz="3600" spc="-67" dirty="0">
-                <a:solidFill>
-                  <a:srgbClr val="212D73"/>
-                </a:solidFill>
-              </a:rPr>
-              <a:t>1</a:t>
-            </a:r>
-            <a:endParaRPr sz="3600"/>
-          </a:p>
-          <a:p>
-            <a:pPr marL="16933"/>
-            <a:r>
-              <a:rPr sz="3600" dirty="0">
-                <a:solidFill>
-                  <a:srgbClr val="D13368"/>
-                </a:solidFill>
-              </a:rPr>
-              <a:t>Plugin</a:t>
-            </a:r>
-            <a:r>
-              <a:rPr sz="3600" spc="-53" dirty="0">
-                <a:solidFill>
-                  <a:srgbClr val="D13368"/>
-                </a:solidFill>
-              </a:rPr>
-              <a:t> </a:t>
-            </a:r>
-            <a:r>
-              <a:rPr sz="3600" dirty="0">
-                <a:solidFill>
-                  <a:srgbClr val="D13368"/>
-                </a:solidFill>
-              </a:rPr>
-              <a:t>and</a:t>
-            </a:r>
-            <a:r>
-              <a:rPr sz="3600" spc="-40" dirty="0">
-                <a:solidFill>
-                  <a:srgbClr val="D13368"/>
-                </a:solidFill>
-              </a:rPr>
-              <a:t> </a:t>
-            </a:r>
-            <a:r>
-              <a:rPr sz="3600" dirty="0">
-                <a:solidFill>
-                  <a:srgbClr val="D13368"/>
-                </a:solidFill>
-              </a:rPr>
-              <a:t>ensure</a:t>
-            </a:r>
-            <a:r>
-              <a:rPr sz="3600" spc="-33" dirty="0">
-                <a:solidFill>
-                  <a:srgbClr val="D13368"/>
-                </a:solidFill>
-              </a:rPr>
-              <a:t> </a:t>
-            </a:r>
-            <a:r>
-              <a:rPr sz="3600" dirty="0">
-                <a:solidFill>
-                  <a:srgbClr val="D13368"/>
-                </a:solidFill>
-              </a:rPr>
-              <a:t>HackRF</a:t>
-            </a:r>
-            <a:r>
-              <a:rPr sz="3600" spc="-40" dirty="0">
-                <a:solidFill>
-                  <a:srgbClr val="D13368"/>
-                </a:solidFill>
-              </a:rPr>
-              <a:t> </a:t>
-            </a:r>
-            <a:r>
-              <a:rPr sz="3600" dirty="0">
-                <a:solidFill>
-                  <a:srgbClr val="D13368"/>
-                </a:solidFill>
-              </a:rPr>
-              <a:t>is</a:t>
-            </a:r>
-            <a:r>
-              <a:rPr sz="3600" spc="-33" dirty="0">
-                <a:solidFill>
-                  <a:srgbClr val="D13368"/>
-                </a:solidFill>
-              </a:rPr>
-              <a:t> </a:t>
-            </a:r>
-            <a:r>
-              <a:rPr sz="3600" spc="-13" dirty="0">
-                <a:solidFill>
-                  <a:srgbClr val="D13368"/>
-                </a:solidFill>
-              </a:rPr>
-              <a:t>working</a:t>
-            </a:r>
-            <a:endParaRPr sz="3600"/>
+            <a:br>
+              <a:rPr lang="en-US" sz="3600" dirty="0"/>
+            </a:br>
+            <a:endParaRPr sz="3600" dirty="0"/>
           </a:p>
         </p:txBody>
       </p:sp>
-      <p:sp>
-        <p:nvSpPr>
-          <p:cNvPr id="3" name="object 3"/>
-          <p:cNvSpPr txBox="1"/>
+      <p:pic>
+        <p:nvPicPr>
+          <p:cNvPr id="11" name="Picture 10">
+            <a:extLst>
+              <a:ext uri="{FF2B5EF4-FFF2-40B4-BE49-F238E27FC236}">
+                <a16:creationId xmlns:a16="http://schemas.microsoft.com/office/drawing/2014/main" id="{4A9036FA-12F1-EBD6-8614-D7824DA0EAC9}"/>
+              </a:ext>
+            </a:extLst>
+          </p:cNvPr>
+          <p:cNvPicPr>
+            <a:picLocks noChangeAspect="1"/>
+          </p:cNvPicPr>
           <p:nvPr/>
-        </p:nvSpPr>
+        </p:nvPicPr>
+        <p:blipFill>
+          <a:blip r:embed="rId4"/>
+          <a:stretch>
+            <a:fillRect/>
+          </a:stretch>
+        </p:blipFill>
         <p:spPr>
           <a:xfrm>
-            <a:off x="710241" y="1737529"/>
-            <a:ext cx="4410287" cy="1442340"/>
+            <a:off x="1943100" y="2231001"/>
+            <a:ext cx="8115300" cy="4307911"/>
           </a:xfrm>
           <a:prstGeom prst="rect">
             <a:avLst/>
           </a:prstGeom>
         </p:spPr>
-        <p:txBody>
-          <a:bodyPr vert="horz" wrap="square" lIns="0" tIns="186267" rIns="0" bIns="0" rtlCol="0">
-            <a:spAutoFit/>
-          </a:bodyPr>
-          <a:lstStyle/>
-          <a:p>
-            <a:pPr marL="585031" indent="-568098" defTabSz="1219170">
-              <a:spcBef>
-                <a:spcPts val="1467"/>
-              </a:spcBef>
-              <a:buFont typeface="Roboto"/>
-              <a:buAutoNum type="arabicPeriod"/>
-              <a:tabLst>
-                <a:tab pos="585031" algn="l"/>
-              </a:tabLst>
-            </a:pPr>
-            <a:r>
-              <a:rPr sz="2400" kern="0" dirty="0">
-                <a:solidFill>
-                  <a:srgbClr val="434343"/>
-                </a:solidFill>
-                <a:latin typeface="Roboto"/>
-                <a:cs typeface="Roboto"/>
-              </a:rPr>
-              <a:t>Plugin</a:t>
-            </a:r>
-            <a:r>
-              <a:rPr sz="2400" kern="0" spc="-40" dirty="0">
-                <a:solidFill>
-                  <a:srgbClr val="434343"/>
-                </a:solidFill>
-                <a:latin typeface="Roboto"/>
-                <a:cs typeface="Roboto"/>
-              </a:rPr>
-              <a:t> </a:t>
-            </a:r>
-            <a:r>
-              <a:rPr sz="2400" kern="0" spc="-13" dirty="0">
-                <a:solidFill>
-                  <a:srgbClr val="434343"/>
-                </a:solidFill>
-                <a:latin typeface="Roboto"/>
-                <a:cs typeface="Roboto"/>
-              </a:rPr>
-              <a:t>hackRF</a:t>
-            </a:r>
-            <a:endParaRPr sz="2400" kern="0">
-              <a:solidFill>
-                <a:sysClr val="windowText" lastClr="000000"/>
-              </a:solidFill>
-              <a:latin typeface="Roboto"/>
-              <a:cs typeface="Roboto"/>
-            </a:endParaRPr>
-          </a:p>
-          <a:p>
-            <a:pPr marL="585031" indent="-568098" defTabSz="1219170">
-              <a:spcBef>
-                <a:spcPts val="1333"/>
-              </a:spcBef>
-              <a:buFont typeface="Roboto"/>
-              <a:buAutoNum type="arabicPeriod"/>
-              <a:tabLst>
-                <a:tab pos="585031" algn="l"/>
-              </a:tabLst>
-            </a:pPr>
-            <a:r>
-              <a:rPr sz="2400" kern="0" dirty="0">
-                <a:solidFill>
-                  <a:srgbClr val="434343"/>
-                </a:solidFill>
-                <a:latin typeface="Roboto"/>
-                <a:cs typeface="Roboto"/>
-              </a:rPr>
-              <a:t>Ensure</a:t>
-            </a:r>
-            <a:r>
-              <a:rPr sz="2400" kern="0" spc="-40" dirty="0">
-                <a:solidFill>
-                  <a:srgbClr val="434343"/>
-                </a:solidFill>
-                <a:latin typeface="Roboto"/>
-                <a:cs typeface="Roboto"/>
-              </a:rPr>
-              <a:t> </a:t>
-            </a:r>
-            <a:r>
-              <a:rPr sz="2400" kern="0" dirty="0">
-                <a:solidFill>
-                  <a:srgbClr val="434343"/>
-                </a:solidFill>
-                <a:latin typeface="Roboto"/>
-                <a:cs typeface="Roboto"/>
-              </a:rPr>
-              <a:t>hackRF</a:t>
-            </a:r>
-            <a:r>
-              <a:rPr sz="2400" kern="0" spc="-40" dirty="0">
-                <a:solidFill>
-                  <a:srgbClr val="434343"/>
-                </a:solidFill>
-                <a:latin typeface="Roboto"/>
-                <a:cs typeface="Roboto"/>
-              </a:rPr>
-              <a:t> </a:t>
-            </a:r>
-            <a:r>
-              <a:rPr sz="2400" kern="0" dirty="0">
-                <a:solidFill>
-                  <a:srgbClr val="434343"/>
-                </a:solidFill>
-                <a:latin typeface="Roboto"/>
-                <a:cs typeface="Roboto"/>
-              </a:rPr>
-              <a:t>is</a:t>
-            </a:r>
-            <a:r>
-              <a:rPr sz="2400" kern="0" spc="-33" dirty="0">
-                <a:solidFill>
-                  <a:srgbClr val="434343"/>
-                </a:solidFill>
-                <a:latin typeface="Roboto"/>
-                <a:cs typeface="Roboto"/>
-              </a:rPr>
-              <a:t> </a:t>
-            </a:r>
-            <a:r>
-              <a:rPr sz="2400" kern="0" spc="-13" dirty="0">
-                <a:solidFill>
-                  <a:srgbClr val="434343"/>
-                </a:solidFill>
-                <a:latin typeface="Roboto"/>
-                <a:cs typeface="Roboto"/>
-              </a:rPr>
-              <a:t>connected</a:t>
-            </a:r>
-            <a:endParaRPr sz="2400" kern="0">
-              <a:solidFill>
-                <a:sysClr val="windowText" lastClr="000000"/>
-              </a:solidFill>
-              <a:latin typeface="Roboto"/>
-              <a:cs typeface="Roboto"/>
-            </a:endParaRPr>
-          </a:p>
-          <a:p>
-            <a:pPr marL="1194617" defTabSz="1219170"/>
-            <a:r>
-              <a:rPr sz="2267" b="1" kern="0" spc="-13" dirty="0">
-                <a:solidFill>
-                  <a:srgbClr val="D13368"/>
-                </a:solidFill>
-                <a:latin typeface="Courier New"/>
-                <a:cs typeface="Courier New"/>
-              </a:rPr>
-              <a:t>hackrf_info</a:t>
-            </a:r>
-            <a:endParaRPr sz="2267" kern="0">
-              <a:solidFill>
-                <a:sysClr val="windowText" lastClr="000000"/>
-              </a:solidFill>
-              <a:latin typeface="Courier New"/>
-              <a:cs typeface="Courier New"/>
-            </a:endParaRPr>
-          </a:p>
-        </p:txBody>
-      </p:sp>
-      <p:grpSp>
-        <p:nvGrpSpPr>
-          <p:cNvPr id="4" name="object 4"/>
-          <p:cNvGrpSpPr/>
-          <p:nvPr/>
-        </p:nvGrpSpPr>
-        <p:grpSpPr>
-          <a:xfrm>
-            <a:off x="2473666" y="3393900"/>
-            <a:ext cx="6635327" cy="3024293"/>
-            <a:chOff x="1855249" y="2545425"/>
-            <a:chExt cx="4976495" cy="2268220"/>
-          </a:xfrm>
-        </p:grpSpPr>
-        <p:pic>
-          <p:nvPicPr>
-            <p:cNvPr id="5" name="object 5"/>
-            <p:cNvPicPr/>
-            <p:nvPr/>
-          </p:nvPicPr>
-          <p:blipFill>
-            <a:blip r:embed="rId3" cstate="print"/>
-            <a:stretch>
-              <a:fillRect/>
-            </a:stretch>
-          </p:blipFill>
-          <p:spPr>
-            <a:xfrm>
-              <a:off x="1864775" y="2554950"/>
-              <a:ext cx="4957250" cy="2248650"/>
-            </a:xfrm>
-            <a:prstGeom prst="rect">
-              <a:avLst/>
-            </a:prstGeom>
-          </p:spPr>
-        </p:pic>
-        <p:sp>
-          <p:nvSpPr>
-            <p:cNvPr id="6" name="object 6"/>
-            <p:cNvSpPr/>
-            <p:nvPr/>
-          </p:nvSpPr>
-          <p:spPr>
-            <a:xfrm>
-              <a:off x="1860012" y="2550187"/>
-              <a:ext cx="4966970" cy="2258695"/>
-            </a:xfrm>
-            <a:custGeom>
-              <a:avLst/>
-              <a:gdLst/>
-              <a:ahLst/>
-              <a:cxnLst/>
-              <a:rect l="l" t="t" r="r" b="b"/>
-              <a:pathLst>
-                <a:path w="4966970" h="2258695">
-                  <a:moveTo>
-                    <a:pt x="0" y="0"/>
-                  </a:moveTo>
-                  <a:lnTo>
-                    <a:pt x="4966775" y="0"/>
-                  </a:lnTo>
-                  <a:lnTo>
-                    <a:pt x="4966775" y="2258175"/>
-                  </a:lnTo>
-                  <a:lnTo>
-                    <a:pt x="0" y="2258175"/>
-                  </a:lnTo>
-                  <a:lnTo>
-                    <a:pt x="0" y="0"/>
-                  </a:lnTo>
-                  <a:close/>
-                </a:path>
-              </a:pathLst>
-            </a:custGeom>
-            <a:ln w="9524">
-              <a:solidFill>
-                <a:srgbClr val="434343"/>
-              </a:solidFill>
-            </a:ln>
-          </p:spPr>
-          <p:txBody>
-            <a:bodyPr wrap="square" lIns="0" tIns="0" rIns="0" bIns="0" rtlCol="0"/>
-            <a:lstStyle/>
-            <a:p>
-              <a:pPr defTabSz="1219170"/>
-              <a:endParaRPr sz="2400" kern="0">
-                <a:solidFill>
-                  <a:sysClr val="windowText" lastClr="000000"/>
-                </a:solidFill>
-              </a:endParaRPr>
-            </a:p>
-          </p:txBody>
-        </p:sp>
-      </p:grpSp>
+      </p:pic>
     </p:spTree>
     <p:custDataLst>
       <p:tags r:id="rId1"/>
@@ -7972,7 +7358,7 @@
 </file>
 
 <file path=ppt/slides/slide4.xml><?xml version="1.0" encoding="utf-8"?>
-<p:sld xmlns:a="http://schemas.openxmlformats.org/drawingml/2006/main" xmlns:r="http://schemas.openxmlformats.org/officeDocument/2006/relationships" xmlns:p="http://schemas.openxmlformats.org/presentationml/2006/main" showMasterSp="0">
+<p:sld xmlns:a="http://schemas.openxmlformats.org/drawingml/2006/main" xmlns:r="http://schemas.openxmlformats.org/officeDocument/2006/relationships" xmlns:p="http://schemas.openxmlformats.org/presentationml/2006/main">
   <p:cSld>
     <p:spTree>
       <p:nvGrpSpPr>
@@ -7990,7 +7376,153 @@
       </p:grpSpPr>
       <p:sp>
         <p:nvSpPr>
-          <p:cNvPr id="4" name="object 4"/>
+          <p:cNvPr id="2" name="Title 1">
+            <a:extLst>
+              <a:ext uri="{FF2B5EF4-FFF2-40B4-BE49-F238E27FC236}">
+                <a16:creationId xmlns:a16="http://schemas.microsoft.com/office/drawing/2014/main" id="{83FD2FA3-69E4-E045-0B0C-7836DE4C7457}"/>
+              </a:ext>
+            </a:extLst>
+          </p:cNvPr>
+          <p:cNvSpPr>
+            <a:spLocks noGrp="1"/>
+          </p:cNvSpPr>
+          <p:nvPr>
+            <p:ph type="title"/>
+          </p:nvPr>
+        </p:nvSpPr>
+        <p:spPr/>
+        <p:txBody>
+          <a:bodyPr/>
+          <a:lstStyle/>
+          <a:p>
+            <a:r>
+              <a:rPr lang="en-US" dirty="0"/>
+              <a:t>GPS Messages</a:t>
+            </a:r>
+          </a:p>
+        </p:txBody>
+      </p:sp>
+      <p:sp>
+        <p:nvSpPr>
+          <p:cNvPr id="3" name="Content Placeholder 2">
+            <a:extLst>
+              <a:ext uri="{FF2B5EF4-FFF2-40B4-BE49-F238E27FC236}">
+                <a16:creationId xmlns:a16="http://schemas.microsoft.com/office/drawing/2014/main" id="{FA0169FC-CAFD-B4F9-ED17-1F6062320727}"/>
+              </a:ext>
+            </a:extLst>
+          </p:cNvPr>
+          <p:cNvSpPr>
+            <a:spLocks noGrp="1"/>
+          </p:cNvSpPr>
+          <p:nvPr>
+            <p:ph idx="1"/>
+          </p:nvPr>
+        </p:nvSpPr>
+        <p:spPr/>
+        <p:txBody>
+          <a:bodyPr/>
+          <a:lstStyle/>
+          <a:p>
+            <a:r>
+              <a:rPr lang="en-US" dirty="0"/>
+              <a:t>GPS Messages</a:t>
+            </a:r>
+          </a:p>
+          <a:p>
+            <a:pPr lvl="1"/>
+            <a:r>
+              <a:rPr lang="en-US" dirty="0"/>
+              <a:t>Text messages in ASCII sent by serial port to you</a:t>
+            </a:r>
+          </a:p>
+          <a:p>
+            <a:pPr lvl="1"/>
+            <a:r>
+              <a:rPr lang="en-US" dirty="0"/>
+              <a:t>Many message types</a:t>
+            </a:r>
+          </a:p>
+          <a:p>
+            <a:pPr lvl="1"/>
+            <a:r>
+              <a:rPr lang="en-US" dirty="0"/>
+              <a:t>Show satellite constellation</a:t>
+            </a:r>
+          </a:p>
+          <a:p>
+            <a:pPr lvl="1"/>
+            <a:r>
+              <a:rPr lang="en-US" dirty="0"/>
+              <a:t>Give you position and movement</a:t>
+            </a:r>
+          </a:p>
+          <a:p>
+            <a:r>
+              <a:rPr lang="en-US" dirty="0"/>
+              <a:t>Where are we?</a:t>
+            </a:r>
+          </a:p>
+          <a:p>
+            <a:pPr lvl="1"/>
+            <a:r>
+              <a:rPr lang="en-US" dirty="0"/>
+              <a:t>Latitude &amp; Longitude</a:t>
+            </a:r>
+          </a:p>
+          <a:p>
+            <a:pPr lvl="1"/>
+            <a:endParaRPr lang="en-US" dirty="0"/>
+          </a:p>
+        </p:txBody>
+      </p:sp>
+    </p:spTree>
+    <p:extLst>
+      <p:ext uri="{BB962C8B-B14F-4D97-AF65-F5344CB8AC3E}">
+        <p14:creationId xmlns:p14="http://schemas.microsoft.com/office/powerpoint/2010/main" val="3458458323"/>
+      </p:ext>
+    </p:extLst>
+  </p:cSld>
+  <p:clrMapOvr>
+    <a:masterClrMapping/>
+  </p:clrMapOvr>
+  <p:transition>
+    <p:fade/>
+  </p:transition>
+</p:sld>
+</file>
+
+<file path=ppt/slides/slide5.xml><?xml version="1.0" encoding="utf-8"?>
+<p:sld xmlns:a="http://schemas.openxmlformats.org/drawingml/2006/main" xmlns:r="http://schemas.openxmlformats.org/officeDocument/2006/relationships" xmlns:p="http://schemas.openxmlformats.org/presentationml/2006/main" showMasterSp="0">
+  <p:cSld>
+    <p:spTree>
+      <p:nvGrpSpPr>
+        <p:cNvPr id="1" name="">
+          <a:extLst>
+            <a:ext uri="{FF2B5EF4-FFF2-40B4-BE49-F238E27FC236}">
+              <a16:creationId xmlns:a16="http://schemas.microsoft.com/office/drawing/2014/main" id="{22D98400-DAC5-B95F-D542-2C4B4CDAB443}"/>
+            </a:ext>
+          </a:extLst>
+        </p:cNvPr>
+        <p:cNvGrpSpPr/>
+        <p:nvPr/>
+      </p:nvGrpSpPr>
+      <p:grpSpPr>
+        <a:xfrm>
+          <a:off x="0" y="0"/>
+          <a:ext cx="0" cy="0"/>
+          <a:chOff x="0" y="0"/>
+          <a:chExt cx="0" cy="0"/>
+        </a:xfrm>
+      </p:grpSpPr>
+      <p:sp>
+        <p:nvSpPr>
+          <p:cNvPr id="7" name="object 7">
+            <a:extLst>
+              <a:ext uri="{FF2B5EF4-FFF2-40B4-BE49-F238E27FC236}">
+                <a16:creationId xmlns:a16="http://schemas.microsoft.com/office/drawing/2014/main" id="{18D58AD4-9DFF-B37A-8F0F-3A5112F02718}"/>
+              </a:ext>
+            </a:extLst>
+          </p:cNvPr>
           <p:cNvSpPr txBox="1">
             <a:spLocks noGrp="1"/>
           </p:cNvSpPr>
@@ -8021,7 +7553,7 @@
                   <a:spcPts val="2193"/>
                 </a:lnSpc>
               </a:pPr>
-              <a:t>4</a:t>
+              <a:t>5</a:t>
             </a:fld>
             <a:endParaRPr kern="0" spc="-33" dirty="0"/>
           </a:p>
@@ -8029,7 +7561,13 @@
       </p:sp>
       <p:sp>
         <p:nvSpPr>
-          <p:cNvPr id="2" name="object 2" descr="$PPTXTitle"/>
+          <p:cNvPr id="2" name="object 2" descr="$PPTXTitle">
+            <a:extLst>
+              <a:ext uri="{FF2B5EF4-FFF2-40B4-BE49-F238E27FC236}">
+                <a16:creationId xmlns:a16="http://schemas.microsoft.com/office/drawing/2014/main" id="{46EDA983-D330-1B62-1696-3268D82949CB}"/>
+              </a:ext>
+            </a:extLst>
+          </p:cNvPr>
           <p:cNvSpPr txBox="1">
             <a:spLocks noGrp="1"/>
           </p:cNvSpPr>
@@ -8039,429 +7577,89 @@
         </p:nvSpPr>
         <p:spPr>
           <a:xfrm>
-            <a:off x="0" y="910157"/>
-            <a:ext cx="9096375" cy="685615"/>
+            <a:off x="0" y="430195"/>
+            <a:ext cx="11558016" cy="1516098"/>
           </a:xfrm>
           <a:prstGeom prst="rect">
             <a:avLst/>
           </a:prstGeom>
         </p:spPr>
         <p:txBody>
-          <a:bodyPr vert="horz" wrap="square" lIns="0" tIns="182033" rIns="0" bIns="0" rtlCol="0">
+          <a:bodyPr vert="horz" wrap="square" lIns="0" tIns="16933" rIns="0" bIns="0" rtlCol="0">
             <a:spAutoFit/>
           </a:bodyPr>
           <a:lstStyle/>
           <a:p>
-            <a:pPr marL="131230">
+            <a:pPr marL="16933">
               <a:spcBef>
                 <a:spcPts val="133"/>
               </a:spcBef>
             </a:pPr>
             <a:r>
               <a:rPr sz="3600" dirty="0"/>
-              <a:t>Backup</a:t>
+              <a:t>GPS</a:t>
             </a:r>
             <a:r>
-              <a:rPr sz="3600" spc="-20" dirty="0"/>
+              <a:rPr sz="3600" spc="-33" dirty="0"/>
               <a:t> </a:t>
             </a:r>
             <a:r>
-              <a:rPr sz="3600" dirty="0">
-                <a:solidFill>
-                  <a:srgbClr val="2A3890"/>
-                </a:solidFill>
-              </a:rPr>
-              <a:t>-</a:t>
+              <a:rPr lang="en-US" sz="3600" dirty="0"/>
+              <a:t>View</a:t>
             </a:r>
+            <a:br>
+              <a:rPr lang="en-US" sz="3600" dirty="0"/>
+            </a:br>
+            <a:br>
+              <a:rPr lang="en-US" sz="3600" dirty="0"/>
+            </a:br>
             <a:r>
-              <a:rPr sz="3600" spc="-13" dirty="0">
-                <a:solidFill>
-                  <a:srgbClr val="2A3890"/>
-                </a:solidFill>
-              </a:rPr>
-              <a:t> </a:t>
-            </a:r>
-            <a:r>
-              <a:rPr sz="3600" dirty="0">
-                <a:solidFill>
-                  <a:srgbClr val="2A3890"/>
-                </a:solidFill>
-              </a:rPr>
-              <a:t>Install</a:t>
-            </a:r>
-            <a:r>
-              <a:rPr sz="3600" spc="-20" dirty="0">
-                <a:solidFill>
-                  <a:srgbClr val="2A3890"/>
-                </a:solidFill>
-              </a:rPr>
-              <a:t> </a:t>
-            </a:r>
-            <a:r>
-              <a:rPr sz="3600" spc="-13" dirty="0">
-                <a:solidFill>
-                  <a:srgbClr val="2A3890"/>
-                </a:solidFill>
-              </a:rPr>
-              <a:t>gps-sdr-</a:t>
-            </a:r>
-            <a:r>
-              <a:rPr sz="3600" spc="-33" dirty="0">
-                <a:solidFill>
-                  <a:srgbClr val="2A3890"/>
-                </a:solidFill>
-              </a:rPr>
-              <a:t>sim</a:t>
+              <a:rPr lang="en-US" sz="3600" dirty="0"/>
+              <a:t>See the constellation and where you are</a:t>
             </a:r>
             <a:endParaRPr sz="3600" dirty="0"/>
           </a:p>
         </p:txBody>
       </p:sp>
-      <p:sp>
-        <p:nvSpPr>
-          <p:cNvPr id="3" name="object 3"/>
-          <p:cNvSpPr txBox="1"/>
+      <p:pic>
+        <p:nvPicPr>
+          <p:cNvPr id="4" name="Picture 3">
+            <a:extLst>
+              <a:ext uri="{FF2B5EF4-FFF2-40B4-BE49-F238E27FC236}">
+                <a16:creationId xmlns:a16="http://schemas.microsoft.com/office/drawing/2014/main" id="{7B426EB1-02EA-E903-4575-925785FDCFD9}"/>
+              </a:ext>
+            </a:extLst>
+          </p:cNvPr>
+          <p:cNvPicPr>
+            <a:picLocks noChangeAspect="1"/>
+          </p:cNvPicPr>
           <p:nvPr/>
-        </p:nvSpPr>
+        </p:nvPicPr>
+        <p:blipFill>
+          <a:blip r:embed="rId3"/>
+          <a:stretch>
+            <a:fillRect/>
+          </a:stretch>
+        </p:blipFill>
         <p:spPr>
           <a:xfrm>
-            <a:off x="748341" y="1935309"/>
-            <a:ext cx="7590367" cy="1283258"/>
+            <a:off x="1368933" y="1946293"/>
+            <a:ext cx="8820150" cy="4683101"/>
           </a:xfrm>
           <a:prstGeom prst="rect">
             <a:avLst/>
           </a:prstGeom>
         </p:spPr>
-        <p:txBody>
-          <a:bodyPr vert="horz" wrap="square" lIns="0" tIns="71967" rIns="0" bIns="0" rtlCol="0">
-            <a:spAutoFit/>
-          </a:bodyPr>
-          <a:lstStyle/>
-          <a:p>
-            <a:pPr marL="585031" indent="-568098" defTabSz="1219170">
-              <a:spcBef>
-                <a:spcPts val="567"/>
-              </a:spcBef>
-              <a:buFont typeface="Roboto"/>
-              <a:buAutoNum type="arabicPeriod"/>
-              <a:tabLst>
-                <a:tab pos="585031" algn="l"/>
-              </a:tabLst>
-            </a:pPr>
-            <a:r>
-              <a:rPr sz="2400" kern="0" dirty="0">
-                <a:solidFill>
-                  <a:srgbClr val="434343"/>
-                </a:solidFill>
-                <a:latin typeface="Roboto"/>
-                <a:cs typeface="Roboto"/>
-              </a:rPr>
-              <a:t>git</a:t>
-            </a:r>
-            <a:r>
-              <a:rPr sz="2400" kern="0" spc="140" dirty="0">
-                <a:solidFill>
-                  <a:srgbClr val="434343"/>
-                </a:solidFill>
-                <a:latin typeface="Roboto"/>
-                <a:cs typeface="Roboto"/>
-              </a:rPr>
-              <a:t> </a:t>
-            </a:r>
-            <a:r>
-              <a:rPr sz="2400" kern="0" dirty="0">
-                <a:solidFill>
-                  <a:srgbClr val="434343"/>
-                </a:solidFill>
-                <a:latin typeface="Roboto"/>
-                <a:cs typeface="Roboto"/>
-              </a:rPr>
-              <a:t>clone</a:t>
-            </a:r>
-            <a:r>
-              <a:rPr sz="2400" kern="0" spc="160" dirty="0">
-                <a:solidFill>
-                  <a:srgbClr val="434343"/>
-                </a:solidFill>
-                <a:latin typeface="Roboto"/>
-                <a:cs typeface="Roboto"/>
-              </a:rPr>
-              <a:t> </a:t>
-            </a:r>
-            <a:r>
-              <a:rPr sz="2400" u="heavy" kern="0" spc="-27" dirty="0">
-                <a:solidFill>
-                  <a:srgbClr val="F06292"/>
-                </a:solidFill>
-                <a:uFill>
-                  <a:solidFill>
-                    <a:srgbClr val="F06292"/>
-                  </a:solidFill>
-                </a:uFill>
-                <a:latin typeface="Roboto"/>
-                <a:cs typeface="Roboto"/>
-                <a:hlinkClick r:id="rId3"/>
-              </a:rPr>
-              <a:t>https://github.com/osqzss/gps-</a:t>
-            </a:r>
-            <a:r>
-              <a:rPr sz="2400" u="heavy" kern="0" spc="-13" dirty="0">
-                <a:solidFill>
-                  <a:srgbClr val="F06292"/>
-                </a:solidFill>
-                <a:uFill>
-                  <a:solidFill>
-                    <a:srgbClr val="F06292"/>
-                  </a:solidFill>
-                </a:uFill>
-                <a:latin typeface="Roboto"/>
-                <a:cs typeface="Roboto"/>
-                <a:hlinkClick r:id="rId3"/>
-              </a:rPr>
-              <a:t>sdr-sim.git</a:t>
-            </a:r>
-            <a:endParaRPr sz="2400" kern="0">
-              <a:solidFill>
-                <a:sysClr val="windowText" lastClr="000000"/>
-              </a:solidFill>
-              <a:latin typeface="Roboto"/>
-              <a:cs typeface="Roboto"/>
-            </a:endParaRPr>
-          </a:p>
-          <a:p>
-            <a:pPr marL="585031" indent="-568098" defTabSz="1219170">
-              <a:spcBef>
-                <a:spcPts val="427"/>
-              </a:spcBef>
-              <a:buFont typeface="Roboto"/>
-              <a:buAutoNum type="arabicPeriod"/>
-              <a:tabLst>
-                <a:tab pos="585031" algn="l"/>
-              </a:tabLst>
-            </a:pPr>
-            <a:r>
-              <a:rPr sz="2400" kern="0" dirty="0">
-                <a:solidFill>
-                  <a:srgbClr val="434343"/>
-                </a:solidFill>
-                <a:latin typeface="Roboto"/>
-                <a:cs typeface="Roboto"/>
-              </a:rPr>
-              <a:t>cd</a:t>
-            </a:r>
-            <a:r>
-              <a:rPr sz="2400" kern="0" spc="40" dirty="0">
-                <a:solidFill>
-                  <a:srgbClr val="434343"/>
-                </a:solidFill>
-                <a:latin typeface="Roboto"/>
-                <a:cs typeface="Roboto"/>
-              </a:rPr>
-              <a:t> </a:t>
-            </a:r>
-            <a:r>
-              <a:rPr sz="2400" kern="0" spc="-13" dirty="0">
-                <a:solidFill>
-                  <a:srgbClr val="434343"/>
-                </a:solidFill>
-                <a:latin typeface="Roboto"/>
-                <a:cs typeface="Roboto"/>
-              </a:rPr>
-              <a:t>gps-sdr-</a:t>
-            </a:r>
-            <a:r>
-              <a:rPr sz="2400" kern="0" spc="-27" dirty="0">
-                <a:solidFill>
-                  <a:srgbClr val="434343"/>
-                </a:solidFill>
-                <a:latin typeface="Roboto"/>
-                <a:cs typeface="Roboto"/>
-              </a:rPr>
-              <a:t>sim/</a:t>
-            </a:r>
-            <a:endParaRPr sz="2400" kern="0">
-              <a:solidFill>
-                <a:sysClr val="windowText" lastClr="000000"/>
-              </a:solidFill>
-              <a:latin typeface="Roboto"/>
-              <a:cs typeface="Roboto"/>
-            </a:endParaRPr>
-          </a:p>
-          <a:p>
-            <a:pPr marL="585031" indent="-568098" defTabSz="1219170">
-              <a:spcBef>
-                <a:spcPts val="433"/>
-              </a:spcBef>
-              <a:buFont typeface="Roboto"/>
-              <a:buAutoNum type="arabicPeriod"/>
-              <a:tabLst>
-                <a:tab pos="585031" algn="l"/>
-              </a:tabLst>
-            </a:pPr>
-            <a:r>
-              <a:rPr sz="2400" kern="0" dirty="0">
-                <a:solidFill>
-                  <a:srgbClr val="434343"/>
-                </a:solidFill>
-                <a:latin typeface="Roboto"/>
-                <a:cs typeface="Roboto"/>
-              </a:rPr>
-              <a:t>gcc</a:t>
-            </a:r>
-            <a:r>
-              <a:rPr sz="2400" kern="0" spc="-27" dirty="0">
-                <a:solidFill>
-                  <a:srgbClr val="434343"/>
-                </a:solidFill>
-                <a:latin typeface="Roboto"/>
-                <a:cs typeface="Roboto"/>
-              </a:rPr>
-              <a:t> </a:t>
-            </a:r>
-            <a:r>
-              <a:rPr sz="2400" kern="0" dirty="0">
-                <a:solidFill>
-                  <a:srgbClr val="434343"/>
-                </a:solidFill>
-                <a:latin typeface="Roboto"/>
-                <a:cs typeface="Roboto"/>
-              </a:rPr>
-              <a:t>gpssim.c</a:t>
-            </a:r>
-            <a:r>
-              <a:rPr sz="2400" kern="0" spc="-20" dirty="0">
-                <a:solidFill>
-                  <a:srgbClr val="434343"/>
-                </a:solidFill>
-                <a:latin typeface="Roboto"/>
-                <a:cs typeface="Roboto"/>
-              </a:rPr>
-              <a:t> </a:t>
-            </a:r>
-            <a:r>
-              <a:rPr sz="2400" kern="0" spc="-13" dirty="0">
-                <a:solidFill>
-                  <a:srgbClr val="434343"/>
-                </a:solidFill>
-                <a:latin typeface="Roboto"/>
-                <a:cs typeface="Roboto"/>
-              </a:rPr>
-              <a:t>-</a:t>
-            </a:r>
-            <a:r>
-              <a:rPr sz="2400" kern="0" dirty="0">
-                <a:solidFill>
-                  <a:srgbClr val="434343"/>
-                </a:solidFill>
-                <a:latin typeface="Roboto"/>
-                <a:cs typeface="Roboto"/>
-              </a:rPr>
-              <a:t>lm</a:t>
-            </a:r>
-            <a:r>
-              <a:rPr sz="2400" kern="0" spc="-20" dirty="0">
-                <a:solidFill>
-                  <a:srgbClr val="434343"/>
-                </a:solidFill>
-                <a:latin typeface="Roboto"/>
-                <a:cs typeface="Roboto"/>
-              </a:rPr>
-              <a:t> </a:t>
-            </a:r>
-            <a:r>
-              <a:rPr sz="2400" kern="0" spc="-13" dirty="0">
-                <a:solidFill>
-                  <a:srgbClr val="434343"/>
-                </a:solidFill>
-                <a:latin typeface="Roboto"/>
-                <a:cs typeface="Roboto"/>
-              </a:rPr>
-              <a:t>-</a:t>
-            </a:r>
-            <a:r>
-              <a:rPr sz="2400" kern="0" dirty="0">
-                <a:solidFill>
-                  <a:srgbClr val="434343"/>
-                </a:solidFill>
-                <a:latin typeface="Roboto"/>
-                <a:cs typeface="Roboto"/>
-              </a:rPr>
-              <a:t>O3</a:t>
-            </a:r>
-            <a:r>
-              <a:rPr sz="2400" kern="0" spc="-20" dirty="0">
-                <a:solidFill>
-                  <a:srgbClr val="434343"/>
-                </a:solidFill>
-                <a:latin typeface="Roboto"/>
-                <a:cs typeface="Roboto"/>
-              </a:rPr>
-              <a:t> </a:t>
-            </a:r>
-            <a:r>
-              <a:rPr sz="2400" kern="0" spc="-13" dirty="0">
-                <a:solidFill>
-                  <a:srgbClr val="434343"/>
-                </a:solidFill>
-                <a:latin typeface="Roboto"/>
-                <a:cs typeface="Roboto"/>
-              </a:rPr>
-              <a:t>-</a:t>
-            </a:r>
-            <a:r>
-              <a:rPr sz="2400" kern="0" dirty="0">
-                <a:solidFill>
-                  <a:srgbClr val="434343"/>
-                </a:solidFill>
-                <a:latin typeface="Roboto"/>
-                <a:cs typeface="Roboto"/>
-              </a:rPr>
-              <a:t>o</a:t>
-            </a:r>
-            <a:r>
-              <a:rPr sz="2400" kern="0" spc="-20" dirty="0">
-                <a:solidFill>
-                  <a:srgbClr val="434343"/>
-                </a:solidFill>
-                <a:latin typeface="Roboto"/>
-                <a:cs typeface="Roboto"/>
-              </a:rPr>
-              <a:t> </a:t>
-            </a:r>
-            <a:r>
-              <a:rPr sz="2400" kern="0" spc="-27" dirty="0">
-                <a:solidFill>
-                  <a:srgbClr val="434343"/>
-                </a:solidFill>
-                <a:latin typeface="Roboto"/>
-                <a:cs typeface="Roboto"/>
-              </a:rPr>
-              <a:t>gps-sdr-</a:t>
-            </a:r>
-            <a:r>
-              <a:rPr sz="2400" kern="0" spc="-33" dirty="0">
-                <a:solidFill>
-                  <a:srgbClr val="434343"/>
-                </a:solidFill>
-                <a:latin typeface="Roboto"/>
-                <a:cs typeface="Roboto"/>
-              </a:rPr>
-              <a:t>sim</a:t>
-            </a:r>
-            <a:endParaRPr sz="2400" kern="0">
-              <a:solidFill>
-                <a:sysClr val="windowText" lastClr="000000"/>
-              </a:solidFill>
-              <a:latin typeface="Roboto"/>
-              <a:cs typeface="Roboto"/>
-            </a:endParaRPr>
-          </a:p>
-        </p:txBody>
-      </p:sp>
+      </p:pic>
     </p:spTree>
     <p:custDataLst>
       <p:tags r:id="rId1"/>
     </p:custDataLst>
+    <p:extLst>
+      <p:ext uri="{BB962C8B-B14F-4D97-AF65-F5344CB8AC3E}">
+        <p14:creationId xmlns:p14="http://schemas.microsoft.com/office/powerpoint/2010/main" val="118803321"/>
+      </p:ext>
+    </p:extLst>
   </p:cSld>
   <p:clrMapOvr>
     <a:masterClrMapping/>
@@ -8469,12 +7667,18 @@
 </p:sld>
 </file>
 
-<file path=ppt/slides/slide5.xml><?xml version="1.0" encoding="utf-8"?>
-<p:sld xmlns:a="http://schemas.openxmlformats.org/drawingml/2006/main" xmlns:r="http://schemas.openxmlformats.org/officeDocument/2006/relationships" xmlns:p="http://schemas.openxmlformats.org/presentationml/2006/main" showMasterSp="0">
+<file path=ppt/slides/slide6.xml><?xml version="1.0" encoding="utf-8"?>
+<p:sld xmlns:a="http://schemas.openxmlformats.org/drawingml/2006/main" xmlns:r="http://schemas.openxmlformats.org/officeDocument/2006/relationships" xmlns:p="http://schemas.openxmlformats.org/presentationml/2006/main">
   <p:cSld>
     <p:spTree>
       <p:nvGrpSpPr>
-        <p:cNvPr id="1" name=""/>
+        <p:cNvPr id="1" name="">
+          <a:extLst>
+            <a:ext uri="{FF2B5EF4-FFF2-40B4-BE49-F238E27FC236}">
+              <a16:creationId xmlns:a16="http://schemas.microsoft.com/office/drawing/2014/main" id="{1D98B71F-2888-933E-537B-DC15DFCC6D37}"/>
+            </a:ext>
+          </a:extLst>
+        </p:cNvPr>
         <p:cNvGrpSpPr/>
         <p:nvPr/>
       </p:nvGrpSpPr>
@@ -8488,2619 +7692,109 @@
       </p:grpSpPr>
       <p:sp>
         <p:nvSpPr>
-          <p:cNvPr id="5" name="object 5"/>
-          <p:cNvSpPr txBox="1">
+          <p:cNvPr id="2" name="Title 1">
+            <a:extLst>
+              <a:ext uri="{FF2B5EF4-FFF2-40B4-BE49-F238E27FC236}">
+                <a16:creationId xmlns:a16="http://schemas.microsoft.com/office/drawing/2014/main" id="{C1CC9BE7-CDB3-7737-E169-8ED3F6F35861}"/>
+              </a:ext>
+            </a:extLst>
+          </p:cNvPr>
+          <p:cNvSpPr>
             <a:spLocks noGrp="1"/>
           </p:cNvSpPr>
           <p:nvPr>
-            <p:ph type="sldNum" sz="quarter" idx="12"/>
+            <p:ph type="title"/>
           </p:nvPr>
         </p:nvSpPr>
-        <p:spPr>
-          <a:prstGeom prst="rect">
-            <a:avLst/>
-          </a:prstGeom>
-        </p:spPr>
+        <p:spPr/>
         <p:txBody>
-          <a:bodyPr vert="horz" wrap="square" lIns="0" tIns="0" rIns="0" bIns="0" rtlCol="0">
-            <a:spAutoFit/>
-          </a:bodyPr>
+          <a:bodyPr/>
           <a:lstStyle/>
           <a:p>
-            <a:pPr marL="50799" defTabSz="1219170">
-              <a:lnSpc>
-                <a:spcPts val="2193"/>
-              </a:lnSpc>
-            </a:pPr>
-            <a:fld id="{81D60167-4931-47E6-BA6A-407CBD079E47}" type="slidenum">
-              <a:rPr kern="0" spc="-33" dirty="0"/>
-              <a:pPr marL="50799" defTabSz="1219170">
-                <a:lnSpc>
-                  <a:spcPts val="2193"/>
-                </a:lnSpc>
-              </a:pPr>
-              <a:t>5</a:t>
-            </a:fld>
-            <a:endParaRPr kern="0" spc="-33" dirty="0"/>
+            <a:r>
+              <a:rPr lang="en-US" dirty="0"/>
+              <a:t>GPS Satellites</a:t>
+            </a:r>
           </a:p>
         </p:txBody>
       </p:sp>
       <p:sp>
         <p:nvSpPr>
-          <p:cNvPr id="2" name="object 2" descr="$PPTXTitle"/>
-          <p:cNvSpPr txBox="1">
+          <p:cNvPr id="3" name="Content Placeholder 2">
+            <a:extLst>
+              <a:ext uri="{FF2B5EF4-FFF2-40B4-BE49-F238E27FC236}">
+                <a16:creationId xmlns:a16="http://schemas.microsoft.com/office/drawing/2014/main" id="{71F8FF5E-2139-9C2C-F46C-0106670582FD}"/>
+              </a:ext>
+            </a:extLst>
+          </p:cNvPr>
+          <p:cNvSpPr>
             <a:spLocks noGrp="1"/>
           </p:cNvSpPr>
           <p:nvPr>
-            <p:ph type="title" idx="4294967295"/>
+            <p:ph idx="1"/>
           </p:nvPr>
         </p:nvSpPr>
-        <p:spPr>
-          <a:xfrm>
-            <a:off x="0" y="625475"/>
-            <a:ext cx="6178550" cy="1125538"/>
-          </a:xfrm>
-          <a:prstGeom prst="rect">
-            <a:avLst/>
-          </a:prstGeom>
-        </p:spPr>
+        <p:spPr/>
         <p:txBody>
-          <a:bodyPr vert="horz" wrap="square" lIns="0" tIns="16933" rIns="0" bIns="0" rtlCol="0">
-            <a:spAutoFit/>
-          </a:bodyPr>
+          <a:bodyPr/>
           <a:lstStyle/>
           <a:p>
-            <a:pPr marL="16933" marR="6773">
-              <a:spcBef>
-                <a:spcPts val="133"/>
-              </a:spcBef>
-            </a:pPr>
             <a:r>
-              <a:rPr sz="3600" dirty="0"/>
-              <a:t>GPS</a:t>
+              <a:rPr lang="en-US" dirty="0"/>
+              <a:t>GPS Constellations</a:t>
             </a:r>
+          </a:p>
+          <a:p>
+            <a:pPr lvl="1"/>
             <a:r>
-              <a:rPr sz="3600" spc="-33" dirty="0"/>
-              <a:t> </a:t>
+              <a:rPr lang="en-US" dirty="0"/>
+              <a:t>US GPS with SBAS corrections</a:t>
             </a:r>
+          </a:p>
+          <a:p>
+            <a:pPr lvl="1"/>
             <a:r>
-              <a:rPr sz="3600" dirty="0"/>
-              <a:t>Spooﬁng</a:t>
+              <a:rPr lang="en-US" dirty="0"/>
+              <a:t>European Galileo</a:t>
             </a:r>
+          </a:p>
+          <a:p>
+            <a:pPr lvl="1"/>
             <a:r>
-              <a:rPr sz="3600" spc="-33" dirty="0"/>
-              <a:t> </a:t>
+              <a:rPr lang="en-US" dirty="0"/>
+              <a:t>Chinese BeiDou</a:t>
             </a:r>
+          </a:p>
+          <a:p>
+            <a:pPr lvl="1"/>
             <a:r>
-              <a:rPr sz="3600" dirty="0"/>
-              <a:t>–</a:t>
+              <a:rPr lang="en-US" dirty="0"/>
+              <a:t>Russian GLONAS</a:t>
             </a:r>
-            <a:r>
-              <a:rPr sz="3600" spc="-13" dirty="0"/>
-              <a:t> </a:t>
-            </a:r>
-            <a:r>
-              <a:rPr sz="3600" dirty="0">
-                <a:solidFill>
-                  <a:srgbClr val="212D73"/>
-                </a:solidFill>
-              </a:rPr>
-              <a:t>Step</a:t>
-            </a:r>
-            <a:r>
-              <a:rPr sz="3600" spc="-33" dirty="0">
-                <a:solidFill>
-                  <a:srgbClr val="212D73"/>
-                </a:solidFill>
-              </a:rPr>
-              <a:t> </a:t>
-            </a:r>
-            <a:r>
-              <a:rPr sz="3600" spc="-67" dirty="0">
-                <a:solidFill>
-                  <a:srgbClr val="212D73"/>
-                </a:solidFill>
-              </a:rPr>
-              <a:t>2 </a:t>
-            </a:r>
-            <a:r>
-              <a:rPr sz="3600" dirty="0">
-                <a:solidFill>
-                  <a:srgbClr val="D13368"/>
-                </a:solidFill>
-              </a:rPr>
-              <a:t>Download</a:t>
-            </a:r>
-            <a:r>
-              <a:rPr sz="3600" spc="-53" dirty="0">
-                <a:solidFill>
-                  <a:srgbClr val="D13368"/>
-                </a:solidFill>
-              </a:rPr>
-              <a:t> </a:t>
-            </a:r>
-            <a:r>
-              <a:rPr sz="3600" dirty="0">
-                <a:solidFill>
-                  <a:srgbClr val="D13368"/>
-                </a:solidFill>
-              </a:rPr>
-              <a:t>latest</a:t>
-            </a:r>
-            <a:r>
-              <a:rPr sz="3600" spc="-40" dirty="0">
-                <a:solidFill>
-                  <a:srgbClr val="D13368"/>
-                </a:solidFill>
-              </a:rPr>
-              <a:t> </a:t>
-            </a:r>
-            <a:r>
-              <a:rPr sz="3600" dirty="0">
-                <a:solidFill>
-                  <a:srgbClr val="D13368"/>
-                </a:solidFill>
-              </a:rPr>
-              <a:t>GNSS</a:t>
-            </a:r>
-            <a:r>
-              <a:rPr sz="3600" spc="-40" dirty="0">
-                <a:solidFill>
-                  <a:srgbClr val="D13368"/>
-                </a:solidFill>
-              </a:rPr>
-              <a:t> </a:t>
-            </a:r>
-            <a:r>
-              <a:rPr sz="3600" spc="-13" dirty="0">
-                <a:solidFill>
-                  <a:srgbClr val="D13368"/>
-                </a:solidFill>
-              </a:rPr>
-              <a:t>archive</a:t>
-            </a:r>
-            <a:endParaRPr sz="3600"/>
+          </a:p>
+          <a:p>
+            <a:pPr lvl="1"/>
+            <a:endParaRPr lang="en-US" dirty="0"/>
           </a:p>
         </p:txBody>
       </p:sp>
-      <p:sp>
-        <p:nvSpPr>
-          <p:cNvPr id="3" name="object 3"/>
-          <p:cNvSpPr txBox="1"/>
-          <p:nvPr/>
-        </p:nvSpPr>
-        <p:spPr>
-          <a:xfrm>
-            <a:off x="710241" y="1906863"/>
-            <a:ext cx="8653780" cy="1273853"/>
-          </a:xfrm>
-          <a:prstGeom prst="rect">
-            <a:avLst/>
-          </a:prstGeom>
-        </p:spPr>
-        <p:txBody>
-          <a:bodyPr vert="horz" wrap="square" lIns="0" tIns="16933" rIns="0" bIns="0" rtlCol="0">
-            <a:spAutoFit/>
-          </a:bodyPr>
-          <a:lstStyle/>
-          <a:p>
-            <a:pPr marL="585031" marR="6773" indent="-568946" defTabSz="1219170">
-              <a:spcBef>
-                <a:spcPts val="133"/>
-              </a:spcBef>
-              <a:buFont typeface="Roboto"/>
-              <a:buAutoNum type="arabicPeriod"/>
-              <a:tabLst>
-                <a:tab pos="585031" algn="l"/>
-              </a:tabLst>
-            </a:pPr>
-            <a:r>
-              <a:rPr sz="2000" kern="0" dirty="0">
-                <a:solidFill>
-                  <a:srgbClr val="434343"/>
-                </a:solidFill>
-                <a:latin typeface="Roboto"/>
-                <a:cs typeface="Roboto"/>
-              </a:rPr>
-              <a:t>Go</a:t>
-            </a:r>
-            <a:r>
-              <a:rPr sz="2000" kern="0" spc="-13" dirty="0">
-                <a:solidFill>
-                  <a:srgbClr val="434343"/>
-                </a:solidFill>
-                <a:latin typeface="Roboto"/>
-                <a:cs typeface="Roboto"/>
-              </a:rPr>
-              <a:t> </a:t>
-            </a:r>
-            <a:r>
-              <a:rPr sz="2000" kern="0" spc="-33" dirty="0">
-                <a:solidFill>
-                  <a:srgbClr val="434343"/>
-                </a:solidFill>
-                <a:latin typeface="Roboto"/>
-                <a:cs typeface="Roboto"/>
-              </a:rPr>
-              <a:t>to </a:t>
-            </a:r>
-            <a:r>
-              <a:rPr sz="2000" u="heavy" kern="0" spc="-13" dirty="0">
-                <a:solidFill>
-                  <a:srgbClr val="F06292"/>
-                </a:solidFill>
-                <a:uFill>
-                  <a:solidFill>
-                    <a:srgbClr val="F06292"/>
-                  </a:solidFill>
-                </a:uFill>
-                <a:latin typeface="Roboto"/>
-                <a:cs typeface="Roboto"/>
-                <a:hlinkClick r:id="rId3"/>
-              </a:rPr>
-              <a:t>https://cddis.nasa.gov/archive/gnss/data/daily/2024/brdc/</a:t>
-            </a:r>
-            <a:endParaRPr sz="2000" kern="0" dirty="0">
-              <a:solidFill>
-                <a:sysClr val="windowText" lastClr="000000"/>
-              </a:solidFill>
-              <a:latin typeface="Roboto"/>
-              <a:cs typeface="Roboto"/>
-            </a:endParaRPr>
-          </a:p>
-          <a:p>
-            <a:pPr marL="585031" indent="-568098" defTabSz="1219170">
-              <a:spcBef>
-                <a:spcPts val="1333"/>
-              </a:spcBef>
-              <a:buFont typeface="Roboto"/>
-              <a:buAutoNum type="arabicPeriod"/>
-              <a:tabLst>
-                <a:tab pos="585031" algn="l"/>
-              </a:tabLst>
-            </a:pPr>
-            <a:r>
-              <a:rPr sz="2000" kern="0" dirty="0">
-                <a:solidFill>
-                  <a:srgbClr val="434343"/>
-                </a:solidFill>
-                <a:latin typeface="Roboto"/>
-                <a:cs typeface="Roboto"/>
-              </a:rPr>
-              <a:t>Download</a:t>
-            </a:r>
-            <a:r>
-              <a:rPr sz="2000" kern="0" spc="-60" dirty="0">
-                <a:solidFill>
-                  <a:srgbClr val="434343"/>
-                </a:solidFill>
-                <a:latin typeface="Roboto"/>
-                <a:cs typeface="Roboto"/>
-              </a:rPr>
-              <a:t> </a:t>
-            </a:r>
-            <a:r>
-              <a:rPr sz="2000" kern="0" dirty="0">
-                <a:solidFill>
-                  <a:srgbClr val="434343"/>
-                </a:solidFill>
-                <a:latin typeface="Roboto"/>
-                <a:cs typeface="Roboto"/>
-              </a:rPr>
-              <a:t>the</a:t>
-            </a:r>
-            <a:r>
-              <a:rPr sz="2000" kern="0" spc="-53" dirty="0">
-                <a:solidFill>
-                  <a:srgbClr val="434343"/>
-                </a:solidFill>
-                <a:latin typeface="Roboto"/>
-                <a:cs typeface="Roboto"/>
-              </a:rPr>
-              <a:t> </a:t>
-            </a:r>
-            <a:r>
-              <a:rPr sz="2000" kern="0" dirty="0">
-                <a:solidFill>
-                  <a:srgbClr val="434343"/>
-                </a:solidFill>
-                <a:latin typeface="Roboto"/>
-                <a:cs typeface="Roboto"/>
-              </a:rPr>
-              <a:t>latest</a:t>
-            </a:r>
-            <a:r>
-              <a:rPr sz="2000" kern="0" spc="-53" dirty="0">
-                <a:solidFill>
-                  <a:srgbClr val="434343"/>
-                </a:solidFill>
-                <a:latin typeface="Roboto"/>
-                <a:cs typeface="Roboto"/>
-              </a:rPr>
-              <a:t> </a:t>
-            </a:r>
-            <a:r>
-              <a:rPr sz="2000" kern="0" dirty="0">
-                <a:solidFill>
-                  <a:srgbClr val="434343"/>
-                </a:solidFill>
-                <a:latin typeface="Roboto"/>
-                <a:cs typeface="Roboto"/>
-              </a:rPr>
-              <a:t>archive</a:t>
-            </a:r>
-            <a:r>
-              <a:rPr sz="2000" kern="0" spc="-53" dirty="0">
-                <a:solidFill>
-                  <a:srgbClr val="434343"/>
-                </a:solidFill>
-                <a:latin typeface="Roboto"/>
-                <a:cs typeface="Roboto"/>
-              </a:rPr>
-              <a:t> </a:t>
-            </a:r>
-            <a:r>
-              <a:rPr sz="2000" kern="0" dirty="0">
-                <a:solidFill>
-                  <a:srgbClr val="434343"/>
-                </a:solidFill>
-                <a:latin typeface="Roboto"/>
-                <a:cs typeface="Roboto"/>
-              </a:rPr>
-              <a:t>from</a:t>
-            </a:r>
-            <a:r>
-              <a:rPr sz="2000" kern="0" spc="-53" dirty="0">
-                <a:solidFill>
-                  <a:srgbClr val="434343"/>
-                </a:solidFill>
-                <a:latin typeface="Roboto"/>
-                <a:cs typeface="Roboto"/>
-              </a:rPr>
-              <a:t> </a:t>
-            </a:r>
-            <a:r>
-              <a:rPr sz="2000" kern="0" dirty="0">
-                <a:solidFill>
-                  <a:srgbClr val="434343"/>
-                </a:solidFill>
-                <a:latin typeface="Roboto"/>
-                <a:cs typeface="Roboto"/>
-              </a:rPr>
-              <a:t>today</a:t>
-            </a:r>
-            <a:r>
-              <a:rPr sz="2000" kern="0" spc="-53" dirty="0">
-                <a:solidFill>
-                  <a:srgbClr val="434343"/>
-                </a:solidFill>
-                <a:latin typeface="Roboto"/>
-                <a:cs typeface="Roboto"/>
-              </a:rPr>
-              <a:t> </a:t>
-            </a:r>
-            <a:r>
-              <a:rPr sz="2000" kern="0" spc="-13" dirty="0">
-                <a:solidFill>
-                  <a:srgbClr val="434343"/>
-                </a:solidFill>
-                <a:latin typeface="Roboto"/>
-                <a:cs typeface="Roboto"/>
-              </a:rPr>
-              <a:t>(brdc0370.24n)</a:t>
-            </a:r>
-            <a:endParaRPr sz="2000" kern="0" dirty="0">
-              <a:solidFill>
-                <a:sysClr val="windowText" lastClr="000000"/>
-              </a:solidFill>
-              <a:latin typeface="Roboto"/>
-              <a:cs typeface="Roboto"/>
-            </a:endParaRPr>
-          </a:p>
-          <a:p>
-            <a:pPr marL="585031" indent="-568098" defTabSz="1219170">
-              <a:spcBef>
-                <a:spcPts val="1333"/>
-              </a:spcBef>
-              <a:buFont typeface="Roboto"/>
-              <a:buAutoNum type="arabicPeriod"/>
-              <a:tabLst>
-                <a:tab pos="585031" algn="l"/>
-              </a:tabLst>
-            </a:pPr>
-            <a:r>
-              <a:rPr sz="2000" kern="0" dirty="0">
-                <a:solidFill>
-                  <a:srgbClr val="434343"/>
-                </a:solidFill>
-                <a:latin typeface="Roboto"/>
-                <a:cs typeface="Roboto"/>
-              </a:rPr>
-              <a:t>Place the</a:t>
-            </a:r>
-            <a:r>
-              <a:rPr sz="2000" kern="0" spc="7" dirty="0">
-                <a:solidFill>
-                  <a:srgbClr val="434343"/>
-                </a:solidFill>
-                <a:latin typeface="Roboto"/>
-                <a:cs typeface="Roboto"/>
-              </a:rPr>
-              <a:t> </a:t>
-            </a:r>
-            <a:r>
-              <a:rPr sz="2000" kern="0" dirty="0">
-                <a:solidFill>
-                  <a:srgbClr val="434343"/>
-                </a:solidFill>
-                <a:latin typeface="Roboto"/>
-                <a:cs typeface="Roboto"/>
-              </a:rPr>
-              <a:t>ﬁle</a:t>
-            </a:r>
-            <a:r>
-              <a:rPr sz="2000" kern="0" spc="7" dirty="0">
-                <a:solidFill>
-                  <a:srgbClr val="434343"/>
-                </a:solidFill>
-                <a:latin typeface="Roboto"/>
-                <a:cs typeface="Roboto"/>
-              </a:rPr>
-              <a:t> </a:t>
-            </a:r>
-            <a:r>
-              <a:rPr sz="2000" kern="0" dirty="0">
-                <a:solidFill>
-                  <a:srgbClr val="434343"/>
-                </a:solidFill>
-                <a:latin typeface="Roboto"/>
-                <a:cs typeface="Roboto"/>
-              </a:rPr>
-              <a:t>in</a:t>
-            </a:r>
-            <a:r>
-              <a:rPr sz="2000" kern="0" spc="33" dirty="0">
-                <a:solidFill>
-                  <a:srgbClr val="434343"/>
-                </a:solidFill>
-                <a:latin typeface="Roboto"/>
-                <a:cs typeface="Roboto"/>
-              </a:rPr>
-              <a:t> </a:t>
-            </a:r>
-            <a:r>
-              <a:rPr sz="2000" b="1" kern="0" spc="-33" dirty="0">
-                <a:solidFill>
-                  <a:srgbClr val="D13368"/>
-                </a:solidFill>
-                <a:latin typeface="Courier New"/>
-                <a:cs typeface="Courier New"/>
-              </a:rPr>
-              <a:t>/usr/src/gps-sdr-</a:t>
-            </a:r>
-            <a:r>
-              <a:rPr sz="2000" b="1" kern="0" dirty="0">
-                <a:solidFill>
-                  <a:srgbClr val="D13368"/>
-                </a:solidFill>
-                <a:latin typeface="Courier New"/>
-                <a:cs typeface="Courier New"/>
-              </a:rPr>
-              <a:t>sim</a:t>
-            </a:r>
-            <a:r>
-              <a:rPr sz="2000" b="1" kern="0" spc="13" dirty="0">
-                <a:solidFill>
-                  <a:srgbClr val="D13368"/>
-                </a:solidFill>
-                <a:latin typeface="Courier New"/>
-                <a:cs typeface="Courier New"/>
-              </a:rPr>
-              <a:t> </a:t>
-            </a:r>
-            <a:r>
-              <a:rPr sz="2000" kern="0" spc="-13" dirty="0">
-                <a:solidFill>
-                  <a:srgbClr val="434343"/>
-                </a:solidFill>
-                <a:latin typeface="Roboto"/>
-                <a:cs typeface="Roboto"/>
-              </a:rPr>
-              <a:t>directory</a:t>
-            </a:r>
-            <a:endParaRPr sz="2000" kern="0" dirty="0">
-              <a:solidFill>
-                <a:sysClr val="windowText" lastClr="000000"/>
-              </a:solidFill>
-              <a:latin typeface="Roboto"/>
-              <a:cs typeface="Roboto"/>
-            </a:endParaRPr>
-          </a:p>
-        </p:txBody>
-      </p:sp>
-      <p:pic>
-        <p:nvPicPr>
-          <p:cNvPr id="4" name="object 4"/>
-          <p:cNvPicPr/>
-          <p:nvPr/>
-        </p:nvPicPr>
-        <p:blipFill>
-          <a:blip r:embed="rId4" cstate="print"/>
-          <a:stretch>
-            <a:fillRect/>
-          </a:stretch>
-        </p:blipFill>
-        <p:spPr>
-          <a:xfrm>
-            <a:off x="2156234" y="3538734"/>
-            <a:ext cx="7879533" cy="3133233"/>
-          </a:xfrm>
-          <a:prstGeom prst="rect">
-            <a:avLst/>
-          </a:prstGeom>
-        </p:spPr>
-      </p:pic>
     </p:spTree>
-    <p:custDataLst>
-      <p:tags r:id="rId1"/>
-    </p:custDataLst>
+    <p:extLst>
+      <p:ext uri="{BB962C8B-B14F-4D97-AF65-F5344CB8AC3E}">
+        <p14:creationId xmlns:p14="http://schemas.microsoft.com/office/powerpoint/2010/main" val="1990366231"/>
+      </p:ext>
+    </p:extLst>
   </p:cSld>
   <p:clrMapOvr>
     <a:masterClrMapping/>
   </p:clrMapOvr>
-</p:sld>
-</file>
-
-<file path=ppt/slides/slide6.xml><?xml version="1.0" encoding="utf-8"?>
-<p:sld xmlns:a="http://schemas.openxmlformats.org/drawingml/2006/main" xmlns:r="http://schemas.openxmlformats.org/officeDocument/2006/relationships" xmlns:p="http://schemas.openxmlformats.org/presentationml/2006/main" showMasterSp="0">
-  <p:cSld>
-    <p:spTree>
-      <p:nvGrpSpPr>
-        <p:cNvPr id="1" name=""/>
-        <p:cNvGrpSpPr/>
-        <p:nvPr/>
-      </p:nvGrpSpPr>
-      <p:grpSpPr>
-        <a:xfrm>
-          <a:off x="0" y="0"/>
-          <a:ext cx="0" cy="0"/>
-          <a:chOff x="0" y="0"/>
-          <a:chExt cx="0" cy="0"/>
-        </a:xfrm>
-      </p:grpSpPr>
-      <p:sp>
-        <p:nvSpPr>
-          <p:cNvPr id="5" name="object 5"/>
-          <p:cNvSpPr txBox="1">
-            <a:spLocks noGrp="1"/>
-          </p:cNvSpPr>
-          <p:nvPr>
-            <p:ph type="sldNum" sz="quarter" idx="12"/>
-          </p:nvPr>
-        </p:nvSpPr>
-        <p:spPr>
-          <a:prstGeom prst="rect">
-            <a:avLst/>
-          </a:prstGeom>
-        </p:spPr>
-        <p:txBody>
-          <a:bodyPr vert="horz" wrap="square" lIns="0" tIns="0" rIns="0" bIns="0" rtlCol="0">
-            <a:spAutoFit/>
-          </a:bodyPr>
-          <a:lstStyle/>
-          <a:p>
-            <a:pPr marL="50799" defTabSz="1219170">
-              <a:lnSpc>
-                <a:spcPts val="2193"/>
-              </a:lnSpc>
-            </a:pPr>
-            <a:fld id="{81D60167-4931-47E6-BA6A-407CBD079E47}" type="slidenum">
-              <a:rPr kern="0" spc="-33" dirty="0"/>
-              <a:pPr marL="50799" defTabSz="1219170">
-                <a:lnSpc>
-                  <a:spcPts val="2193"/>
-                </a:lnSpc>
-              </a:pPr>
-              <a:t>6</a:t>
-            </a:fld>
-            <a:endParaRPr kern="0" spc="-33" dirty="0"/>
-          </a:p>
-        </p:txBody>
-      </p:sp>
-      <p:sp>
-        <p:nvSpPr>
-          <p:cNvPr id="2" name="object 2" descr="$PPTXTitle"/>
-          <p:cNvSpPr txBox="1">
-            <a:spLocks noGrp="1"/>
-          </p:cNvSpPr>
-          <p:nvPr>
-            <p:ph type="title" idx="4294967295"/>
-          </p:nvPr>
-        </p:nvSpPr>
-        <p:spPr>
-          <a:xfrm>
-            <a:off x="0" y="625475"/>
-            <a:ext cx="5195888" cy="1125538"/>
-          </a:xfrm>
-          <a:prstGeom prst="rect">
-            <a:avLst/>
-          </a:prstGeom>
-        </p:spPr>
-        <p:txBody>
-          <a:bodyPr vert="horz" wrap="square" lIns="0" tIns="16933" rIns="0" bIns="0" rtlCol="0">
-            <a:spAutoFit/>
-          </a:bodyPr>
-          <a:lstStyle/>
-          <a:p>
-            <a:pPr marL="16933" marR="6773">
-              <a:spcBef>
-                <a:spcPts val="133"/>
-              </a:spcBef>
-            </a:pPr>
-            <a:r>
-              <a:rPr sz="3600" dirty="0"/>
-              <a:t>GPS</a:t>
-            </a:r>
-            <a:r>
-              <a:rPr sz="3600" spc="-33" dirty="0"/>
-              <a:t> </a:t>
-            </a:r>
-            <a:r>
-              <a:rPr sz="3600" dirty="0"/>
-              <a:t>Spooﬁng</a:t>
-            </a:r>
-            <a:r>
-              <a:rPr sz="3600" spc="-33" dirty="0"/>
-              <a:t> </a:t>
-            </a:r>
-            <a:r>
-              <a:rPr sz="3600" dirty="0"/>
-              <a:t>–</a:t>
-            </a:r>
-            <a:r>
-              <a:rPr sz="3600" spc="-13" dirty="0"/>
-              <a:t> </a:t>
-            </a:r>
-            <a:r>
-              <a:rPr sz="3600" dirty="0">
-                <a:solidFill>
-                  <a:srgbClr val="212D73"/>
-                </a:solidFill>
-              </a:rPr>
-              <a:t>Step</a:t>
-            </a:r>
-            <a:r>
-              <a:rPr sz="3600" spc="-33" dirty="0">
-                <a:solidFill>
-                  <a:srgbClr val="212D73"/>
-                </a:solidFill>
-              </a:rPr>
-              <a:t> </a:t>
-            </a:r>
-            <a:r>
-              <a:rPr sz="3600" spc="-67" dirty="0">
-                <a:solidFill>
-                  <a:srgbClr val="212D73"/>
-                </a:solidFill>
-              </a:rPr>
-              <a:t>3 </a:t>
-            </a:r>
-            <a:r>
-              <a:rPr sz="3600" dirty="0">
-                <a:solidFill>
-                  <a:srgbClr val="D13368"/>
-                </a:solidFill>
-              </a:rPr>
-              <a:t>Select</a:t>
-            </a:r>
-            <a:r>
-              <a:rPr sz="3600" spc="-40" dirty="0">
-                <a:solidFill>
-                  <a:srgbClr val="D13368"/>
-                </a:solidFill>
-              </a:rPr>
-              <a:t> </a:t>
-            </a:r>
-            <a:r>
-              <a:rPr sz="3600" dirty="0">
-                <a:solidFill>
-                  <a:srgbClr val="D13368"/>
-                </a:solidFill>
-              </a:rPr>
-              <a:t>a</a:t>
-            </a:r>
-            <a:r>
-              <a:rPr sz="3600" spc="-40" dirty="0">
-                <a:solidFill>
-                  <a:srgbClr val="D13368"/>
-                </a:solidFill>
-              </a:rPr>
-              <a:t> </a:t>
-            </a:r>
-            <a:r>
-              <a:rPr sz="3600" dirty="0">
-                <a:solidFill>
-                  <a:srgbClr val="D13368"/>
-                </a:solidFill>
-              </a:rPr>
-              <a:t>location</a:t>
-            </a:r>
-            <a:r>
-              <a:rPr sz="3600" spc="-40" dirty="0">
-                <a:solidFill>
-                  <a:srgbClr val="D13368"/>
-                </a:solidFill>
-              </a:rPr>
-              <a:t> </a:t>
-            </a:r>
-            <a:r>
-              <a:rPr sz="3600" dirty="0">
-                <a:solidFill>
-                  <a:srgbClr val="D13368"/>
-                </a:solidFill>
-              </a:rPr>
-              <a:t>to</a:t>
-            </a:r>
-            <a:r>
-              <a:rPr sz="3600" spc="-40" dirty="0">
-                <a:solidFill>
-                  <a:srgbClr val="D13368"/>
-                </a:solidFill>
-              </a:rPr>
-              <a:t> </a:t>
-            </a:r>
-            <a:r>
-              <a:rPr sz="3600" spc="-13" dirty="0">
-                <a:solidFill>
-                  <a:srgbClr val="D13368"/>
-                </a:solidFill>
-              </a:rPr>
-              <a:t>spoof</a:t>
-            </a:r>
-            <a:endParaRPr sz="3600"/>
-          </a:p>
-        </p:txBody>
-      </p:sp>
-      <p:sp>
-        <p:nvSpPr>
-          <p:cNvPr id="3" name="object 3"/>
-          <p:cNvSpPr txBox="1"/>
-          <p:nvPr/>
-        </p:nvSpPr>
-        <p:spPr>
-          <a:xfrm>
-            <a:off x="710240" y="1737530"/>
-            <a:ext cx="6644640" cy="1629506"/>
-          </a:xfrm>
-          <a:prstGeom prst="rect">
-            <a:avLst/>
-          </a:prstGeom>
-        </p:spPr>
-        <p:txBody>
-          <a:bodyPr vert="horz" wrap="square" lIns="0" tIns="186267" rIns="0" bIns="0" rtlCol="0">
-            <a:spAutoFit/>
-          </a:bodyPr>
-          <a:lstStyle/>
-          <a:p>
-            <a:pPr marL="585031" indent="-568098" defTabSz="1219170">
-              <a:spcBef>
-                <a:spcPts val="1467"/>
-              </a:spcBef>
-              <a:buFont typeface="Roboto"/>
-              <a:buAutoNum type="arabicPeriod"/>
-              <a:tabLst>
-                <a:tab pos="585031" algn="l"/>
-              </a:tabLst>
-            </a:pPr>
-            <a:r>
-              <a:rPr sz="2400" kern="0" dirty="0">
-                <a:solidFill>
-                  <a:srgbClr val="434343"/>
-                </a:solidFill>
-                <a:latin typeface="Roboto"/>
-                <a:cs typeface="Roboto"/>
-              </a:rPr>
-              <a:t>Navigate</a:t>
-            </a:r>
-            <a:r>
-              <a:rPr sz="2400" kern="0" spc="-53" dirty="0">
-                <a:solidFill>
-                  <a:srgbClr val="434343"/>
-                </a:solidFill>
-                <a:latin typeface="Roboto"/>
-                <a:cs typeface="Roboto"/>
-              </a:rPr>
-              <a:t> </a:t>
-            </a:r>
-            <a:r>
-              <a:rPr sz="2400" kern="0" dirty="0">
-                <a:solidFill>
-                  <a:srgbClr val="434343"/>
-                </a:solidFill>
-                <a:latin typeface="Roboto"/>
-                <a:cs typeface="Roboto"/>
-              </a:rPr>
-              <a:t>to</a:t>
-            </a:r>
-            <a:r>
-              <a:rPr sz="2400" kern="0" spc="-27" dirty="0">
-                <a:solidFill>
-                  <a:srgbClr val="434343"/>
-                </a:solidFill>
-                <a:latin typeface="Roboto"/>
-                <a:cs typeface="Roboto"/>
-              </a:rPr>
-              <a:t> </a:t>
-            </a:r>
-            <a:r>
-              <a:rPr sz="2400" u="heavy" kern="0" spc="-13" dirty="0">
-                <a:solidFill>
-                  <a:srgbClr val="F06292"/>
-                </a:solidFill>
-                <a:uFill>
-                  <a:solidFill>
-                    <a:srgbClr val="F06292"/>
-                  </a:solidFill>
-                </a:uFill>
-                <a:latin typeface="Roboto"/>
-                <a:cs typeface="Roboto"/>
-                <a:hlinkClick r:id="rId3"/>
-              </a:rPr>
-              <a:t>maps.google.com</a:t>
-            </a:r>
-            <a:endParaRPr sz="2400" kern="0">
-              <a:solidFill>
-                <a:sysClr val="windowText" lastClr="000000"/>
-              </a:solidFill>
-              <a:latin typeface="Roboto"/>
-              <a:cs typeface="Roboto"/>
-            </a:endParaRPr>
-          </a:p>
-          <a:p>
-            <a:pPr marL="585031" indent="-568098" defTabSz="1219170">
-              <a:spcBef>
-                <a:spcPts val="1333"/>
-              </a:spcBef>
-              <a:buFont typeface="Roboto"/>
-              <a:buAutoNum type="arabicPeriod"/>
-              <a:tabLst>
-                <a:tab pos="585031" algn="l"/>
-              </a:tabLst>
-            </a:pPr>
-            <a:r>
-              <a:rPr sz="2400" kern="0" dirty="0">
-                <a:solidFill>
-                  <a:srgbClr val="434343"/>
-                </a:solidFill>
-                <a:latin typeface="Roboto"/>
-                <a:cs typeface="Roboto"/>
-              </a:rPr>
-              <a:t>Find</a:t>
-            </a:r>
-            <a:r>
-              <a:rPr sz="2400" kern="0" spc="-47" dirty="0">
-                <a:solidFill>
-                  <a:srgbClr val="434343"/>
-                </a:solidFill>
-                <a:latin typeface="Roboto"/>
-                <a:cs typeface="Roboto"/>
-              </a:rPr>
-              <a:t> </a:t>
-            </a:r>
-            <a:r>
-              <a:rPr sz="2400" kern="0" dirty="0">
-                <a:solidFill>
-                  <a:srgbClr val="434343"/>
-                </a:solidFill>
-                <a:latin typeface="Roboto"/>
-                <a:cs typeface="Roboto"/>
-              </a:rPr>
-              <a:t>a</a:t>
-            </a:r>
-            <a:r>
-              <a:rPr sz="2400" kern="0" spc="-27" dirty="0">
-                <a:solidFill>
-                  <a:srgbClr val="434343"/>
-                </a:solidFill>
-                <a:latin typeface="Roboto"/>
-                <a:cs typeface="Roboto"/>
-              </a:rPr>
-              <a:t> </a:t>
-            </a:r>
-            <a:r>
-              <a:rPr sz="2400" kern="0" dirty="0">
-                <a:solidFill>
-                  <a:srgbClr val="434343"/>
-                </a:solidFill>
-                <a:latin typeface="Roboto"/>
-                <a:cs typeface="Roboto"/>
-              </a:rPr>
-              <a:t>location</a:t>
-            </a:r>
-            <a:r>
-              <a:rPr sz="2400" kern="0" spc="-33" dirty="0">
-                <a:solidFill>
-                  <a:srgbClr val="434343"/>
-                </a:solidFill>
-                <a:latin typeface="Roboto"/>
-                <a:cs typeface="Roboto"/>
-              </a:rPr>
-              <a:t> </a:t>
-            </a:r>
-            <a:r>
-              <a:rPr sz="2400" kern="0" dirty="0">
-                <a:solidFill>
-                  <a:srgbClr val="434343"/>
-                </a:solidFill>
-                <a:latin typeface="Roboto"/>
-                <a:cs typeface="Roboto"/>
-              </a:rPr>
-              <a:t>to</a:t>
-            </a:r>
-            <a:r>
-              <a:rPr sz="2400" kern="0" spc="-27" dirty="0">
-                <a:solidFill>
-                  <a:srgbClr val="434343"/>
-                </a:solidFill>
-                <a:latin typeface="Roboto"/>
-                <a:cs typeface="Roboto"/>
-              </a:rPr>
-              <a:t> </a:t>
-            </a:r>
-            <a:r>
-              <a:rPr sz="2400" kern="0" spc="-13" dirty="0">
-                <a:solidFill>
-                  <a:srgbClr val="434343"/>
-                </a:solidFill>
-                <a:latin typeface="Roboto"/>
-                <a:cs typeface="Roboto"/>
-              </a:rPr>
-              <a:t>spoof</a:t>
-            </a:r>
-            <a:endParaRPr sz="2400" kern="0">
-              <a:solidFill>
-                <a:sysClr val="windowText" lastClr="000000"/>
-              </a:solidFill>
-              <a:latin typeface="Roboto"/>
-              <a:cs typeface="Roboto"/>
-            </a:endParaRPr>
-          </a:p>
-          <a:p>
-            <a:pPr marL="585031" indent="-568098" defTabSz="1219170">
-              <a:spcBef>
-                <a:spcPts val="1333"/>
-              </a:spcBef>
-              <a:buFont typeface="Roboto"/>
-              <a:buAutoNum type="arabicPeriod"/>
-              <a:tabLst>
-                <a:tab pos="585031" algn="l"/>
-              </a:tabLst>
-            </a:pPr>
-            <a:r>
-              <a:rPr sz="2400" kern="0" dirty="0">
-                <a:solidFill>
-                  <a:srgbClr val="434343"/>
-                </a:solidFill>
-                <a:latin typeface="Roboto"/>
-                <a:cs typeface="Roboto"/>
-              </a:rPr>
-              <a:t>Copy</a:t>
-            </a:r>
-            <a:r>
-              <a:rPr sz="2400" kern="0" spc="-47" dirty="0">
-                <a:solidFill>
-                  <a:srgbClr val="434343"/>
-                </a:solidFill>
-                <a:latin typeface="Roboto"/>
-                <a:cs typeface="Roboto"/>
-              </a:rPr>
-              <a:t> </a:t>
-            </a:r>
-            <a:r>
-              <a:rPr sz="2400" kern="0" dirty="0">
-                <a:solidFill>
-                  <a:srgbClr val="434343"/>
-                </a:solidFill>
-                <a:latin typeface="Roboto"/>
-                <a:cs typeface="Roboto"/>
-              </a:rPr>
-              <a:t>the</a:t>
-            </a:r>
-            <a:r>
-              <a:rPr sz="2400" kern="0" spc="-47" dirty="0">
-                <a:solidFill>
-                  <a:srgbClr val="434343"/>
-                </a:solidFill>
-                <a:latin typeface="Roboto"/>
-                <a:cs typeface="Roboto"/>
-              </a:rPr>
-              <a:t> </a:t>
-            </a:r>
-            <a:r>
-              <a:rPr sz="2400" kern="0" dirty="0">
-                <a:solidFill>
-                  <a:srgbClr val="434343"/>
-                </a:solidFill>
-                <a:latin typeface="Roboto"/>
-                <a:cs typeface="Roboto"/>
-              </a:rPr>
-              <a:t>longitude</a:t>
-            </a:r>
-            <a:r>
-              <a:rPr sz="2400" kern="0" spc="-47" dirty="0">
-                <a:solidFill>
-                  <a:srgbClr val="434343"/>
-                </a:solidFill>
-                <a:latin typeface="Roboto"/>
-                <a:cs typeface="Roboto"/>
-              </a:rPr>
-              <a:t> </a:t>
-            </a:r>
-            <a:r>
-              <a:rPr sz="2400" kern="0" dirty="0">
-                <a:solidFill>
-                  <a:srgbClr val="434343"/>
-                </a:solidFill>
-                <a:latin typeface="Roboto"/>
-                <a:cs typeface="Roboto"/>
-              </a:rPr>
-              <a:t>and</a:t>
-            </a:r>
-            <a:r>
-              <a:rPr sz="2400" kern="0" spc="-40" dirty="0">
-                <a:solidFill>
-                  <a:srgbClr val="434343"/>
-                </a:solidFill>
-                <a:latin typeface="Roboto"/>
-                <a:cs typeface="Roboto"/>
-              </a:rPr>
-              <a:t> </a:t>
-            </a:r>
-            <a:r>
-              <a:rPr sz="2400" kern="0" dirty="0">
-                <a:solidFill>
-                  <a:srgbClr val="434343"/>
-                </a:solidFill>
-                <a:latin typeface="Roboto"/>
-                <a:cs typeface="Roboto"/>
-              </a:rPr>
-              <a:t>latitude</a:t>
-            </a:r>
-            <a:r>
-              <a:rPr sz="2400" kern="0" spc="-47" dirty="0">
-                <a:solidFill>
-                  <a:srgbClr val="434343"/>
-                </a:solidFill>
-                <a:latin typeface="Roboto"/>
-                <a:cs typeface="Roboto"/>
-              </a:rPr>
-              <a:t> </a:t>
-            </a:r>
-            <a:r>
-              <a:rPr sz="2400" kern="0" dirty="0">
-                <a:solidFill>
-                  <a:srgbClr val="434343"/>
-                </a:solidFill>
-                <a:latin typeface="Roboto"/>
-                <a:cs typeface="Roboto"/>
-              </a:rPr>
-              <a:t>from</a:t>
-            </a:r>
-            <a:r>
-              <a:rPr sz="2400" kern="0" spc="-47" dirty="0">
-                <a:solidFill>
-                  <a:srgbClr val="434343"/>
-                </a:solidFill>
-                <a:latin typeface="Roboto"/>
-                <a:cs typeface="Roboto"/>
-              </a:rPr>
-              <a:t> </a:t>
-            </a:r>
-            <a:r>
-              <a:rPr sz="2400" kern="0" dirty="0">
-                <a:solidFill>
-                  <a:srgbClr val="434343"/>
-                </a:solidFill>
-                <a:latin typeface="Roboto"/>
-                <a:cs typeface="Roboto"/>
-              </a:rPr>
-              <a:t>the</a:t>
-            </a:r>
-            <a:r>
-              <a:rPr sz="2400" kern="0" spc="-40" dirty="0">
-                <a:solidFill>
-                  <a:srgbClr val="434343"/>
-                </a:solidFill>
-                <a:latin typeface="Roboto"/>
-                <a:cs typeface="Roboto"/>
-              </a:rPr>
-              <a:t> </a:t>
-            </a:r>
-            <a:r>
-              <a:rPr sz="2400" kern="0" spc="-33" dirty="0">
-                <a:solidFill>
-                  <a:srgbClr val="434343"/>
-                </a:solidFill>
-                <a:latin typeface="Roboto"/>
-                <a:cs typeface="Roboto"/>
-              </a:rPr>
-              <a:t>URL</a:t>
-            </a:r>
-            <a:endParaRPr sz="2400" kern="0">
-              <a:solidFill>
-                <a:sysClr val="windowText" lastClr="000000"/>
-              </a:solidFill>
-              <a:latin typeface="Roboto"/>
-              <a:cs typeface="Roboto"/>
-            </a:endParaRPr>
-          </a:p>
-        </p:txBody>
-      </p:sp>
-      <p:pic>
-        <p:nvPicPr>
-          <p:cNvPr id="4" name="object 4"/>
-          <p:cNvPicPr/>
-          <p:nvPr/>
-        </p:nvPicPr>
-        <p:blipFill>
-          <a:blip r:embed="rId4" cstate="email">
-            <a:extLst>
-              <a:ext uri="{28A0092B-C50C-407E-A947-70E740481C1C}">
-                <a14:useLocalDpi xmlns:a14="http://schemas.microsoft.com/office/drawing/2010/main"/>
-              </a:ext>
-            </a:extLst>
-          </a:blip>
-          <a:stretch>
-            <a:fillRect/>
-          </a:stretch>
-        </p:blipFill>
-        <p:spPr>
-          <a:xfrm>
-            <a:off x="2976884" y="3474367"/>
-            <a:ext cx="6238233" cy="3145932"/>
-          </a:xfrm>
-          <a:prstGeom prst="rect">
-            <a:avLst/>
-          </a:prstGeom>
-        </p:spPr>
-      </p:pic>
-    </p:spTree>
-    <p:custDataLst>
-      <p:tags r:id="rId1"/>
-    </p:custDataLst>
-  </p:cSld>
-  <p:clrMapOvr>
-    <a:masterClrMapping/>
-  </p:clrMapOvr>
+  <p:transition>
+    <p:fade/>
+  </p:transition>
 </p:sld>
 </file>
 
 <file path=ppt/slides/slide7.xml><?xml version="1.0" encoding="utf-8"?>
-<p:sld xmlns:a="http://schemas.openxmlformats.org/drawingml/2006/main" xmlns:r="http://schemas.openxmlformats.org/officeDocument/2006/relationships" xmlns:p="http://schemas.openxmlformats.org/presentationml/2006/main" showMasterSp="0">
-  <p:cSld>
-    <p:spTree>
-      <p:nvGrpSpPr>
-        <p:cNvPr id="1" name=""/>
-        <p:cNvGrpSpPr/>
-        <p:nvPr/>
-      </p:nvGrpSpPr>
-      <p:grpSpPr>
-        <a:xfrm>
-          <a:off x="0" y="0"/>
-          <a:ext cx="0" cy="0"/>
-          <a:chOff x="0" y="0"/>
-          <a:chExt cx="0" cy="0"/>
-        </a:xfrm>
-      </p:grpSpPr>
-      <p:sp>
-        <p:nvSpPr>
-          <p:cNvPr id="7" name="object 7"/>
-          <p:cNvSpPr txBox="1">
-            <a:spLocks noGrp="1"/>
-          </p:cNvSpPr>
-          <p:nvPr>
-            <p:ph type="sldNum" sz="quarter" idx="12"/>
-          </p:nvPr>
-        </p:nvSpPr>
-        <p:spPr>
-          <a:prstGeom prst="rect">
-            <a:avLst/>
-          </a:prstGeom>
-        </p:spPr>
-        <p:txBody>
-          <a:bodyPr vert="horz" wrap="square" lIns="0" tIns="0" rIns="0" bIns="0" rtlCol="0">
-            <a:spAutoFit/>
-          </a:bodyPr>
-          <a:lstStyle/>
-          <a:p>
-            <a:pPr marL="50799" defTabSz="1219170">
-              <a:lnSpc>
-                <a:spcPts val="2193"/>
-              </a:lnSpc>
-            </a:pPr>
-            <a:fld id="{81D60167-4931-47E6-BA6A-407CBD079E47}" type="slidenum">
-              <a:rPr kern="0" spc="-33" dirty="0"/>
-              <a:pPr marL="50799" defTabSz="1219170">
-                <a:lnSpc>
-                  <a:spcPts val="2193"/>
-                </a:lnSpc>
-              </a:pPr>
-              <a:t>7</a:t>
-            </a:fld>
-            <a:endParaRPr kern="0" spc="-33" dirty="0"/>
-          </a:p>
-        </p:txBody>
-      </p:sp>
-      <p:sp>
-        <p:nvSpPr>
-          <p:cNvPr id="2" name="object 2" descr="$PPTXTitle"/>
-          <p:cNvSpPr txBox="1">
-            <a:spLocks noGrp="1"/>
-          </p:cNvSpPr>
-          <p:nvPr>
-            <p:ph type="title" idx="4294967295"/>
-          </p:nvPr>
-        </p:nvSpPr>
-        <p:spPr>
-          <a:xfrm>
-            <a:off x="0" y="625475"/>
-            <a:ext cx="4835525" cy="1125538"/>
-          </a:xfrm>
-          <a:prstGeom prst="rect">
-            <a:avLst/>
-          </a:prstGeom>
-        </p:spPr>
-        <p:txBody>
-          <a:bodyPr vert="horz" wrap="square" lIns="0" tIns="16933" rIns="0" bIns="0" rtlCol="0">
-            <a:spAutoFit/>
-          </a:bodyPr>
-          <a:lstStyle/>
-          <a:p>
-            <a:pPr marL="16933" marR="6773">
-              <a:spcBef>
-                <a:spcPts val="133"/>
-              </a:spcBef>
-            </a:pPr>
-            <a:r>
-              <a:rPr sz="3600" dirty="0"/>
-              <a:t>GPS</a:t>
-            </a:r>
-            <a:r>
-              <a:rPr sz="3600" spc="-33" dirty="0"/>
-              <a:t> </a:t>
-            </a:r>
-            <a:r>
-              <a:rPr sz="3600" dirty="0"/>
-              <a:t>Spooﬁng</a:t>
-            </a:r>
-            <a:r>
-              <a:rPr sz="3600" spc="-33" dirty="0"/>
-              <a:t> </a:t>
-            </a:r>
-            <a:r>
-              <a:rPr sz="3600" dirty="0"/>
-              <a:t>–</a:t>
-            </a:r>
-            <a:r>
-              <a:rPr sz="3600" spc="-13" dirty="0"/>
-              <a:t> </a:t>
-            </a:r>
-            <a:r>
-              <a:rPr sz="3600" dirty="0">
-                <a:solidFill>
-                  <a:srgbClr val="212D73"/>
-                </a:solidFill>
-              </a:rPr>
-              <a:t>Step</a:t>
-            </a:r>
-            <a:r>
-              <a:rPr sz="3600" spc="-33" dirty="0">
-                <a:solidFill>
-                  <a:srgbClr val="212D73"/>
-                </a:solidFill>
-              </a:rPr>
-              <a:t> </a:t>
-            </a:r>
-            <a:r>
-              <a:rPr sz="3600" spc="-67" dirty="0">
-                <a:solidFill>
-                  <a:srgbClr val="212D73"/>
-                </a:solidFill>
-              </a:rPr>
-              <a:t>5 </a:t>
-            </a:r>
-            <a:r>
-              <a:rPr sz="3600" dirty="0">
-                <a:solidFill>
-                  <a:srgbClr val="D13368"/>
-                </a:solidFill>
-              </a:rPr>
-              <a:t>Generate</a:t>
-            </a:r>
-            <a:r>
-              <a:rPr sz="3600" spc="-120" dirty="0">
-                <a:solidFill>
-                  <a:srgbClr val="D13368"/>
-                </a:solidFill>
-              </a:rPr>
-              <a:t> </a:t>
-            </a:r>
-            <a:r>
-              <a:rPr sz="3600" spc="-13" dirty="0">
-                <a:solidFill>
-                  <a:srgbClr val="D13368"/>
-                </a:solidFill>
-              </a:rPr>
-              <a:t>constellations</a:t>
-            </a:r>
-            <a:endParaRPr sz="3600"/>
-          </a:p>
-        </p:txBody>
-      </p:sp>
-      <p:sp>
-        <p:nvSpPr>
-          <p:cNvPr id="3" name="object 3"/>
-          <p:cNvSpPr txBox="1"/>
-          <p:nvPr/>
-        </p:nvSpPr>
-        <p:spPr>
-          <a:xfrm>
-            <a:off x="668867" y="1906875"/>
-            <a:ext cx="10114279" cy="1691980"/>
-          </a:xfrm>
-          <a:prstGeom prst="rect">
-            <a:avLst/>
-          </a:prstGeom>
-        </p:spPr>
-        <p:txBody>
-          <a:bodyPr vert="horz" wrap="square" lIns="0" tIns="16933" rIns="0" bIns="0" rtlCol="0">
-            <a:spAutoFit/>
-          </a:bodyPr>
-          <a:lstStyle/>
-          <a:p>
-            <a:pPr marL="625671" indent="-568098" defTabSz="1219170">
-              <a:spcBef>
-                <a:spcPts val="133"/>
-              </a:spcBef>
-              <a:buFont typeface="Roboto"/>
-              <a:buAutoNum type="arabicPeriod"/>
-              <a:tabLst>
-                <a:tab pos="625671" algn="l"/>
-              </a:tabLst>
-            </a:pPr>
-            <a:r>
-              <a:rPr sz="2400" kern="0" dirty="0">
-                <a:solidFill>
-                  <a:srgbClr val="434343"/>
-                </a:solidFill>
-                <a:latin typeface="Roboto"/>
-                <a:cs typeface="Roboto"/>
-              </a:rPr>
-              <a:t>Go</a:t>
-            </a:r>
-            <a:r>
-              <a:rPr sz="2400" kern="0" spc="13" dirty="0">
-                <a:solidFill>
-                  <a:srgbClr val="434343"/>
-                </a:solidFill>
-                <a:latin typeface="Roboto"/>
-                <a:cs typeface="Roboto"/>
-              </a:rPr>
-              <a:t> </a:t>
-            </a:r>
-            <a:r>
-              <a:rPr sz="2400" kern="0" dirty="0">
-                <a:solidFill>
-                  <a:srgbClr val="434343"/>
-                </a:solidFill>
-                <a:latin typeface="Roboto"/>
-                <a:cs typeface="Roboto"/>
-              </a:rPr>
-              <a:t>to</a:t>
-            </a:r>
-            <a:r>
-              <a:rPr sz="2400" kern="0" spc="13" dirty="0">
-                <a:solidFill>
-                  <a:srgbClr val="434343"/>
-                </a:solidFill>
-                <a:latin typeface="Roboto"/>
-                <a:cs typeface="Roboto"/>
-              </a:rPr>
-              <a:t> </a:t>
-            </a:r>
-            <a:r>
-              <a:rPr sz="2400" kern="0" spc="-27" dirty="0">
-                <a:solidFill>
-                  <a:srgbClr val="434343"/>
-                </a:solidFill>
-                <a:latin typeface="Roboto"/>
-                <a:cs typeface="Roboto"/>
-              </a:rPr>
-              <a:t>gps-sdr-</a:t>
-            </a:r>
-            <a:r>
-              <a:rPr sz="2400" kern="0" spc="-33" dirty="0">
-                <a:solidFill>
-                  <a:srgbClr val="434343"/>
-                </a:solidFill>
-                <a:latin typeface="Roboto"/>
-                <a:cs typeface="Roboto"/>
-              </a:rPr>
-              <a:t>sim</a:t>
-            </a:r>
-            <a:endParaRPr sz="2400" kern="0">
-              <a:solidFill>
-                <a:sysClr val="windowText" lastClr="000000"/>
-              </a:solidFill>
-              <a:latin typeface="Roboto"/>
-              <a:cs typeface="Roboto"/>
-            </a:endParaRPr>
-          </a:p>
-          <a:p>
-            <a:pPr marL="1236102" defTabSz="1219170"/>
-            <a:r>
-              <a:rPr sz="2267" b="1" kern="0" dirty="0">
-                <a:solidFill>
-                  <a:srgbClr val="D13368"/>
-                </a:solidFill>
-                <a:latin typeface="Courier New"/>
-                <a:cs typeface="Courier New"/>
-              </a:rPr>
-              <a:t>cd</a:t>
-            </a:r>
-            <a:r>
-              <a:rPr sz="2267" b="1" kern="0" spc="180" dirty="0">
-                <a:solidFill>
-                  <a:srgbClr val="D13368"/>
-                </a:solidFill>
-                <a:latin typeface="Courier New"/>
-                <a:cs typeface="Courier New"/>
-              </a:rPr>
-              <a:t> </a:t>
-            </a:r>
-            <a:r>
-              <a:rPr sz="2267" b="1" kern="0" spc="-33" dirty="0">
-                <a:solidFill>
-                  <a:srgbClr val="D13368"/>
-                </a:solidFill>
-                <a:latin typeface="Courier New"/>
-                <a:cs typeface="Courier New"/>
-              </a:rPr>
-              <a:t>/usr/src/gps-sdr-sim</a:t>
-            </a:r>
-            <a:endParaRPr sz="2267" kern="0">
-              <a:solidFill>
-                <a:sysClr val="windowText" lastClr="000000"/>
-              </a:solidFill>
-              <a:latin typeface="Courier New"/>
-              <a:cs typeface="Courier New"/>
-            </a:endParaRPr>
-          </a:p>
-          <a:p>
-            <a:pPr marL="625671" indent="-568098" defTabSz="1219170">
-              <a:spcBef>
-                <a:spcPts val="400"/>
-              </a:spcBef>
-              <a:buFont typeface="Roboto"/>
-              <a:buAutoNum type="arabicPeriod" startAt="2"/>
-              <a:tabLst>
-                <a:tab pos="625671" algn="l"/>
-              </a:tabLst>
-            </a:pPr>
-            <a:r>
-              <a:rPr sz="2400" kern="0" dirty="0">
-                <a:solidFill>
-                  <a:srgbClr val="434343"/>
-                </a:solidFill>
-                <a:latin typeface="Roboto"/>
-                <a:cs typeface="Roboto"/>
-              </a:rPr>
-              <a:t>Run</a:t>
-            </a:r>
-            <a:r>
-              <a:rPr sz="2400" kern="0" spc="-33" dirty="0">
-                <a:solidFill>
-                  <a:srgbClr val="434343"/>
-                </a:solidFill>
-                <a:latin typeface="Roboto"/>
-                <a:cs typeface="Roboto"/>
-              </a:rPr>
-              <a:t> </a:t>
-            </a:r>
-            <a:r>
-              <a:rPr sz="2400" kern="0" dirty="0">
-                <a:solidFill>
-                  <a:srgbClr val="434343"/>
-                </a:solidFill>
-                <a:latin typeface="Roboto"/>
-                <a:cs typeface="Roboto"/>
-              </a:rPr>
-              <a:t>the</a:t>
-            </a:r>
-            <a:r>
-              <a:rPr sz="2400" kern="0" spc="-33" dirty="0">
-                <a:solidFill>
-                  <a:srgbClr val="434343"/>
-                </a:solidFill>
-                <a:latin typeface="Roboto"/>
-                <a:cs typeface="Roboto"/>
-              </a:rPr>
-              <a:t> </a:t>
-            </a:r>
-            <a:r>
-              <a:rPr sz="2400" kern="0" dirty="0">
-                <a:solidFill>
-                  <a:srgbClr val="434343"/>
-                </a:solidFill>
-                <a:latin typeface="Roboto"/>
-                <a:cs typeface="Roboto"/>
-              </a:rPr>
-              <a:t>following</a:t>
-            </a:r>
-            <a:r>
-              <a:rPr sz="2400" kern="0" spc="-33" dirty="0">
-                <a:solidFill>
-                  <a:srgbClr val="434343"/>
-                </a:solidFill>
-                <a:latin typeface="Roboto"/>
-                <a:cs typeface="Roboto"/>
-              </a:rPr>
-              <a:t> </a:t>
-            </a:r>
-            <a:r>
-              <a:rPr sz="2400" kern="0" spc="-13" dirty="0">
-                <a:solidFill>
-                  <a:srgbClr val="434343"/>
-                </a:solidFill>
-                <a:latin typeface="Roboto"/>
-                <a:cs typeface="Roboto"/>
-              </a:rPr>
-              <a:t>command</a:t>
-            </a:r>
-            <a:endParaRPr sz="2400" kern="0">
-              <a:solidFill>
-                <a:sysClr val="windowText" lastClr="000000"/>
-              </a:solidFill>
-              <a:latin typeface="Roboto"/>
-              <a:cs typeface="Roboto"/>
-            </a:endParaRPr>
-          </a:p>
-          <a:p>
-            <a:pPr marL="16933" defTabSz="1219170">
-              <a:spcBef>
-                <a:spcPts val="1333"/>
-              </a:spcBef>
-            </a:pPr>
-            <a:r>
-              <a:rPr sz="2400" b="1" kern="0" spc="-27" dirty="0">
-                <a:solidFill>
-                  <a:srgbClr val="212D73"/>
-                </a:solidFill>
-                <a:latin typeface="Roboto"/>
-                <a:cs typeface="Roboto"/>
-              </a:rPr>
-              <a:t>./gps-sdr-</a:t>
-            </a:r>
-            <a:r>
-              <a:rPr sz="2400" b="1" kern="0" dirty="0">
-                <a:solidFill>
-                  <a:srgbClr val="212D73"/>
-                </a:solidFill>
-                <a:latin typeface="Roboto"/>
-                <a:cs typeface="Roboto"/>
-              </a:rPr>
-              <a:t>sim</a:t>
-            </a:r>
-            <a:r>
-              <a:rPr sz="2400" b="1" kern="0" spc="7" dirty="0">
-                <a:solidFill>
-                  <a:srgbClr val="212D73"/>
-                </a:solidFill>
-                <a:latin typeface="Roboto"/>
-                <a:cs typeface="Roboto"/>
-              </a:rPr>
-              <a:t> </a:t>
-            </a:r>
-            <a:r>
-              <a:rPr sz="2400" b="1" kern="0" spc="-27" dirty="0">
-                <a:solidFill>
-                  <a:srgbClr val="212D73"/>
-                </a:solidFill>
-                <a:latin typeface="Roboto"/>
-                <a:cs typeface="Roboto"/>
-              </a:rPr>
-              <a:t>-</a:t>
-            </a:r>
-            <a:r>
-              <a:rPr sz="2400" b="1" kern="0" dirty="0">
-                <a:solidFill>
-                  <a:srgbClr val="212D73"/>
-                </a:solidFill>
-                <a:latin typeface="Roboto"/>
-                <a:cs typeface="Roboto"/>
-              </a:rPr>
-              <a:t>e</a:t>
-            </a:r>
-            <a:r>
-              <a:rPr sz="2400" b="1" kern="0" spc="13" dirty="0">
-                <a:solidFill>
-                  <a:srgbClr val="212D73"/>
-                </a:solidFill>
-                <a:latin typeface="Roboto"/>
-                <a:cs typeface="Roboto"/>
-              </a:rPr>
-              <a:t> </a:t>
-            </a:r>
-            <a:r>
-              <a:rPr sz="2400" b="1" kern="0" spc="-13" dirty="0">
-                <a:solidFill>
-                  <a:srgbClr val="212D73"/>
-                </a:solidFill>
-                <a:latin typeface="Roboto"/>
-                <a:cs typeface="Roboto"/>
-              </a:rPr>
-              <a:t>brdc2050.23n</a:t>
-            </a:r>
-            <a:r>
-              <a:rPr sz="2400" b="1" kern="0" spc="7" dirty="0">
-                <a:solidFill>
-                  <a:srgbClr val="212D73"/>
-                </a:solidFill>
-                <a:latin typeface="Roboto"/>
-                <a:cs typeface="Roboto"/>
-              </a:rPr>
-              <a:t> </a:t>
-            </a:r>
-            <a:r>
-              <a:rPr sz="2400" b="1" kern="0" spc="-13" dirty="0">
-                <a:solidFill>
-                  <a:srgbClr val="212D73"/>
-                </a:solidFill>
-                <a:latin typeface="Roboto"/>
-                <a:cs typeface="Roboto"/>
-              </a:rPr>
-              <a:t>-</a:t>
-            </a:r>
-            <a:r>
-              <a:rPr sz="2400" b="1" kern="0" dirty="0">
-                <a:solidFill>
-                  <a:srgbClr val="212D73"/>
-                </a:solidFill>
-                <a:latin typeface="Roboto"/>
-                <a:cs typeface="Roboto"/>
-              </a:rPr>
-              <a:t>l</a:t>
-            </a:r>
-            <a:r>
-              <a:rPr sz="2400" b="1" kern="0" spc="13" dirty="0">
-                <a:solidFill>
-                  <a:srgbClr val="212D73"/>
-                </a:solidFill>
-                <a:latin typeface="Roboto"/>
-                <a:cs typeface="Roboto"/>
-              </a:rPr>
-              <a:t> </a:t>
-            </a:r>
-            <a:r>
-              <a:rPr sz="2400" b="1" kern="0" spc="-27" dirty="0">
-                <a:solidFill>
-                  <a:srgbClr val="212D73"/>
-                </a:solidFill>
-                <a:latin typeface="Roboto"/>
-                <a:cs typeface="Roboto"/>
-              </a:rPr>
-              <a:t>-81.056276,52.7882491,17z</a:t>
-            </a:r>
-            <a:r>
-              <a:rPr sz="2400" b="1" kern="0" spc="7" dirty="0">
-                <a:solidFill>
-                  <a:srgbClr val="212D73"/>
-                </a:solidFill>
-                <a:latin typeface="Roboto"/>
-                <a:cs typeface="Roboto"/>
-              </a:rPr>
-              <a:t> </a:t>
-            </a:r>
-            <a:r>
-              <a:rPr sz="2400" b="1" kern="0" spc="-27" dirty="0">
-                <a:solidFill>
-                  <a:srgbClr val="212D73"/>
-                </a:solidFill>
-                <a:latin typeface="Roboto"/>
-                <a:cs typeface="Roboto"/>
-              </a:rPr>
-              <a:t>-</a:t>
-            </a:r>
-            <a:r>
-              <a:rPr sz="2400" b="1" kern="0" dirty="0">
-                <a:solidFill>
-                  <a:srgbClr val="212D73"/>
-                </a:solidFill>
-                <a:latin typeface="Roboto"/>
-                <a:cs typeface="Roboto"/>
-              </a:rPr>
-              <a:t>b</a:t>
-            </a:r>
-            <a:r>
-              <a:rPr sz="2400" b="1" kern="0" spc="13" dirty="0">
-                <a:solidFill>
-                  <a:srgbClr val="212D73"/>
-                </a:solidFill>
-                <a:latin typeface="Roboto"/>
-                <a:cs typeface="Roboto"/>
-              </a:rPr>
-              <a:t> </a:t>
-            </a:r>
-            <a:r>
-              <a:rPr sz="2400" b="1" kern="0" dirty="0">
-                <a:solidFill>
-                  <a:srgbClr val="212D73"/>
-                </a:solidFill>
-                <a:latin typeface="Roboto"/>
-                <a:cs typeface="Roboto"/>
-              </a:rPr>
-              <a:t>8</a:t>
-            </a:r>
-            <a:r>
-              <a:rPr sz="2400" b="1" kern="0" spc="7" dirty="0">
-                <a:solidFill>
-                  <a:srgbClr val="212D73"/>
-                </a:solidFill>
-                <a:latin typeface="Roboto"/>
-                <a:cs typeface="Roboto"/>
-              </a:rPr>
-              <a:t> </a:t>
-            </a:r>
-            <a:r>
-              <a:rPr sz="2400" b="1" kern="0" spc="-27" dirty="0">
-                <a:solidFill>
-                  <a:srgbClr val="212D73"/>
-                </a:solidFill>
-                <a:latin typeface="Roboto"/>
-                <a:cs typeface="Roboto"/>
-              </a:rPr>
-              <a:t>-</a:t>
-            </a:r>
-            <a:r>
-              <a:rPr sz="2400" b="1" kern="0" dirty="0">
-                <a:solidFill>
-                  <a:srgbClr val="212D73"/>
-                </a:solidFill>
-                <a:latin typeface="Roboto"/>
-                <a:cs typeface="Roboto"/>
-              </a:rPr>
-              <a:t>d</a:t>
-            </a:r>
-            <a:r>
-              <a:rPr sz="2400" b="1" kern="0" spc="13" dirty="0">
-                <a:solidFill>
-                  <a:srgbClr val="212D73"/>
-                </a:solidFill>
-                <a:latin typeface="Roboto"/>
-                <a:cs typeface="Roboto"/>
-              </a:rPr>
-              <a:t> </a:t>
-            </a:r>
-            <a:r>
-              <a:rPr sz="2400" b="1" kern="0" spc="-33" dirty="0">
-                <a:solidFill>
-                  <a:srgbClr val="212D73"/>
-                </a:solidFill>
-                <a:latin typeface="Roboto"/>
-                <a:cs typeface="Roboto"/>
-              </a:rPr>
-              <a:t>500</a:t>
-            </a:r>
-            <a:endParaRPr sz="2400" kern="0">
-              <a:solidFill>
-                <a:sysClr val="windowText" lastClr="000000"/>
-              </a:solidFill>
-              <a:latin typeface="Roboto"/>
-              <a:cs typeface="Roboto"/>
-            </a:endParaRPr>
-          </a:p>
-        </p:txBody>
-      </p:sp>
-      <p:grpSp>
-        <p:nvGrpSpPr>
-          <p:cNvPr id="4" name="object 4"/>
-          <p:cNvGrpSpPr/>
-          <p:nvPr/>
-        </p:nvGrpSpPr>
-        <p:grpSpPr>
-          <a:xfrm>
-            <a:off x="4150749" y="3658467"/>
-            <a:ext cx="3891280" cy="3136053"/>
-            <a:chOff x="3113062" y="2743850"/>
-            <a:chExt cx="2918460" cy="2352040"/>
-          </a:xfrm>
-        </p:grpSpPr>
-        <p:pic>
-          <p:nvPicPr>
-            <p:cNvPr id="5" name="object 5"/>
-            <p:cNvPicPr/>
-            <p:nvPr/>
-          </p:nvPicPr>
-          <p:blipFill>
-            <a:blip r:embed="rId3" cstate="email">
-              <a:extLst>
-                <a:ext uri="{28A0092B-C50C-407E-A947-70E740481C1C}">
-                  <a14:useLocalDpi xmlns:a14="http://schemas.microsoft.com/office/drawing/2010/main"/>
-                </a:ext>
-              </a:extLst>
-            </a:blip>
-            <a:stretch>
-              <a:fillRect/>
-            </a:stretch>
-          </p:blipFill>
-          <p:spPr>
-            <a:xfrm>
-              <a:off x="3122587" y="2753375"/>
-              <a:ext cx="2898820" cy="2332449"/>
-            </a:xfrm>
-            <a:prstGeom prst="rect">
-              <a:avLst/>
-            </a:prstGeom>
-          </p:spPr>
-        </p:pic>
-        <p:sp>
-          <p:nvSpPr>
-            <p:cNvPr id="6" name="object 6"/>
-            <p:cNvSpPr/>
-            <p:nvPr/>
-          </p:nvSpPr>
-          <p:spPr>
-            <a:xfrm>
-              <a:off x="3117824" y="2748612"/>
-              <a:ext cx="2908935" cy="2342515"/>
-            </a:xfrm>
-            <a:custGeom>
-              <a:avLst/>
-              <a:gdLst/>
-              <a:ahLst/>
-              <a:cxnLst/>
-              <a:rect l="l" t="t" r="r" b="b"/>
-              <a:pathLst>
-                <a:path w="2908935" h="2342515">
-                  <a:moveTo>
-                    <a:pt x="0" y="0"/>
-                  </a:moveTo>
-                  <a:lnTo>
-                    <a:pt x="2908346" y="0"/>
-                  </a:lnTo>
-                  <a:lnTo>
-                    <a:pt x="2908346" y="2341974"/>
-                  </a:lnTo>
-                  <a:lnTo>
-                    <a:pt x="0" y="2341974"/>
-                  </a:lnTo>
-                  <a:lnTo>
-                    <a:pt x="0" y="0"/>
-                  </a:lnTo>
-                  <a:close/>
-                </a:path>
-              </a:pathLst>
-            </a:custGeom>
-            <a:ln w="9524">
-              <a:solidFill>
-                <a:srgbClr val="434343"/>
-              </a:solidFill>
-            </a:ln>
-          </p:spPr>
-          <p:txBody>
-            <a:bodyPr wrap="square" lIns="0" tIns="0" rIns="0" bIns="0" rtlCol="0"/>
-            <a:lstStyle/>
-            <a:p>
-              <a:pPr defTabSz="1219170"/>
-              <a:endParaRPr sz="2400" kern="0">
-                <a:solidFill>
-                  <a:sysClr val="windowText" lastClr="000000"/>
-                </a:solidFill>
-              </a:endParaRPr>
-            </a:p>
-          </p:txBody>
-        </p:sp>
-      </p:grpSp>
-    </p:spTree>
-    <p:custDataLst>
-      <p:tags r:id="rId1"/>
-    </p:custDataLst>
-  </p:cSld>
-  <p:clrMapOvr>
-    <a:masterClrMapping/>
-  </p:clrMapOvr>
-</p:sld>
-</file>
-
-<file path=ppt/slides/slide8.xml><?xml version="1.0" encoding="utf-8"?>
-<p:sld xmlns:a="http://schemas.openxmlformats.org/drawingml/2006/main" xmlns:r="http://schemas.openxmlformats.org/officeDocument/2006/relationships" xmlns:p="http://schemas.openxmlformats.org/presentationml/2006/main" showMasterSp="0">
-  <p:cSld>
-    <p:spTree>
-      <p:nvGrpSpPr>
-        <p:cNvPr id="1" name=""/>
-        <p:cNvGrpSpPr/>
-        <p:nvPr/>
-      </p:nvGrpSpPr>
-      <p:grpSpPr>
-        <a:xfrm>
-          <a:off x="0" y="0"/>
-          <a:ext cx="0" cy="0"/>
-          <a:chOff x="0" y="0"/>
-          <a:chExt cx="0" cy="0"/>
-        </a:xfrm>
-      </p:grpSpPr>
-      <p:sp>
-        <p:nvSpPr>
-          <p:cNvPr id="5" name="object 5"/>
-          <p:cNvSpPr txBox="1">
-            <a:spLocks noGrp="1"/>
-          </p:cNvSpPr>
-          <p:nvPr>
-            <p:ph type="sldNum" sz="quarter" idx="12"/>
-          </p:nvPr>
-        </p:nvSpPr>
-        <p:spPr>
-          <a:prstGeom prst="rect">
-            <a:avLst/>
-          </a:prstGeom>
-        </p:spPr>
-        <p:txBody>
-          <a:bodyPr vert="horz" wrap="square" lIns="0" tIns="0" rIns="0" bIns="0" rtlCol="0">
-            <a:spAutoFit/>
-          </a:bodyPr>
-          <a:lstStyle/>
-          <a:p>
-            <a:pPr marL="50799" defTabSz="1219170">
-              <a:lnSpc>
-                <a:spcPts val="2193"/>
-              </a:lnSpc>
-            </a:pPr>
-            <a:fld id="{81D60167-4931-47E6-BA6A-407CBD079E47}" type="slidenum">
-              <a:rPr kern="0" spc="-33" dirty="0"/>
-              <a:pPr marL="50799" defTabSz="1219170">
-                <a:lnSpc>
-                  <a:spcPts val="2193"/>
-                </a:lnSpc>
-              </a:pPr>
-              <a:t>8</a:t>
-            </a:fld>
-            <a:endParaRPr kern="0" spc="-33" dirty="0"/>
-          </a:p>
-        </p:txBody>
-      </p:sp>
-      <p:sp>
-        <p:nvSpPr>
-          <p:cNvPr id="2" name="object 2" descr="$PPTXTitle"/>
-          <p:cNvSpPr txBox="1">
-            <a:spLocks noGrp="1"/>
-          </p:cNvSpPr>
-          <p:nvPr>
-            <p:ph type="title" idx="4294967295"/>
-          </p:nvPr>
-        </p:nvSpPr>
-        <p:spPr>
-          <a:xfrm>
-            <a:off x="0" y="625475"/>
-            <a:ext cx="6508750" cy="1125538"/>
-          </a:xfrm>
-          <a:prstGeom prst="rect">
-            <a:avLst/>
-          </a:prstGeom>
-        </p:spPr>
-        <p:txBody>
-          <a:bodyPr vert="horz" wrap="square" lIns="0" tIns="16933" rIns="0" bIns="0" rtlCol="0">
-            <a:spAutoFit/>
-          </a:bodyPr>
-          <a:lstStyle/>
-          <a:p>
-            <a:pPr marL="16933" marR="6773">
-              <a:spcBef>
-                <a:spcPts val="133"/>
-              </a:spcBef>
-            </a:pPr>
-            <a:r>
-              <a:rPr sz="3600" dirty="0"/>
-              <a:t>GPS</a:t>
-            </a:r>
-            <a:r>
-              <a:rPr sz="3600" spc="-33" dirty="0"/>
-              <a:t> </a:t>
-            </a:r>
-            <a:r>
-              <a:rPr sz="3600" dirty="0"/>
-              <a:t>Spooﬁng</a:t>
-            </a:r>
-            <a:r>
-              <a:rPr sz="3600" spc="-33" dirty="0"/>
-              <a:t> </a:t>
-            </a:r>
-            <a:r>
-              <a:rPr sz="3600" dirty="0"/>
-              <a:t>–</a:t>
-            </a:r>
-            <a:r>
-              <a:rPr sz="3600" spc="-13" dirty="0"/>
-              <a:t> </a:t>
-            </a:r>
-            <a:r>
-              <a:rPr sz="3600" dirty="0">
-                <a:solidFill>
-                  <a:srgbClr val="212D73"/>
-                </a:solidFill>
-              </a:rPr>
-              <a:t>Step</a:t>
-            </a:r>
-            <a:r>
-              <a:rPr sz="3600" spc="-33" dirty="0">
-                <a:solidFill>
-                  <a:srgbClr val="212D73"/>
-                </a:solidFill>
-              </a:rPr>
-              <a:t> </a:t>
-            </a:r>
-            <a:r>
-              <a:rPr sz="3600" spc="-67" dirty="0">
-                <a:solidFill>
-                  <a:srgbClr val="212D73"/>
-                </a:solidFill>
-              </a:rPr>
-              <a:t>6</a:t>
-            </a:r>
-            <a:r>
-              <a:rPr sz="3600" spc="900" dirty="0">
-                <a:solidFill>
-                  <a:srgbClr val="212D73"/>
-                </a:solidFill>
-              </a:rPr>
-              <a:t> </a:t>
-            </a:r>
-            <a:r>
-              <a:rPr sz="3600" spc="-13" dirty="0">
-                <a:solidFill>
-                  <a:srgbClr val="D13368"/>
-                </a:solidFill>
-              </a:rPr>
-              <a:t>Transmit</a:t>
-            </a:r>
-            <a:r>
-              <a:rPr sz="3600" spc="-93" dirty="0">
-                <a:solidFill>
-                  <a:srgbClr val="D13368"/>
-                </a:solidFill>
-              </a:rPr>
-              <a:t> </a:t>
-            </a:r>
-            <a:r>
-              <a:rPr sz="3600" dirty="0">
-                <a:solidFill>
-                  <a:srgbClr val="D13368"/>
-                </a:solidFill>
-              </a:rPr>
-              <a:t>Spoofed</a:t>
-            </a:r>
-            <a:r>
-              <a:rPr sz="3600" spc="-87" dirty="0">
-                <a:solidFill>
-                  <a:srgbClr val="D13368"/>
-                </a:solidFill>
-              </a:rPr>
-              <a:t> </a:t>
-            </a:r>
-            <a:r>
-              <a:rPr sz="3600" dirty="0">
-                <a:solidFill>
-                  <a:srgbClr val="D13368"/>
-                </a:solidFill>
-              </a:rPr>
-              <a:t>GPS</a:t>
-            </a:r>
-            <a:r>
-              <a:rPr sz="3600" spc="-93" dirty="0">
-                <a:solidFill>
-                  <a:srgbClr val="D13368"/>
-                </a:solidFill>
-              </a:rPr>
-              <a:t> </a:t>
-            </a:r>
-            <a:r>
-              <a:rPr sz="3600" spc="-13" dirty="0">
-                <a:solidFill>
-                  <a:srgbClr val="D13368"/>
-                </a:solidFill>
-              </a:rPr>
-              <a:t>Location</a:t>
-            </a:r>
-            <a:endParaRPr sz="3600"/>
-          </a:p>
-        </p:txBody>
-      </p:sp>
-      <p:sp>
-        <p:nvSpPr>
-          <p:cNvPr id="3" name="object 3"/>
-          <p:cNvSpPr txBox="1"/>
-          <p:nvPr/>
-        </p:nvSpPr>
-        <p:spPr>
-          <a:xfrm>
-            <a:off x="668867" y="1737541"/>
-            <a:ext cx="9788312" cy="1093462"/>
-          </a:xfrm>
-          <a:prstGeom prst="rect">
-            <a:avLst/>
-          </a:prstGeom>
-        </p:spPr>
-        <p:txBody>
-          <a:bodyPr vert="horz" wrap="square" lIns="0" tIns="186267" rIns="0" bIns="0" rtlCol="0">
-            <a:spAutoFit/>
-          </a:bodyPr>
-          <a:lstStyle/>
-          <a:p>
-            <a:pPr marL="57572" defTabSz="1219170">
-              <a:spcBef>
-                <a:spcPts val="1467"/>
-              </a:spcBef>
-              <a:tabLst>
-                <a:tab pos="625671" algn="l"/>
-              </a:tabLst>
-            </a:pPr>
-            <a:r>
-              <a:rPr sz="2400" b="1" kern="0" spc="-33" dirty="0">
-                <a:solidFill>
-                  <a:srgbClr val="434343"/>
-                </a:solidFill>
-                <a:latin typeface="Roboto"/>
-                <a:cs typeface="Roboto"/>
-              </a:rPr>
-              <a:t>1.</a:t>
-            </a:r>
-            <a:r>
-              <a:rPr sz="2400" b="1" kern="0" dirty="0">
-                <a:solidFill>
-                  <a:srgbClr val="434343"/>
-                </a:solidFill>
-                <a:latin typeface="Roboto"/>
-                <a:cs typeface="Roboto"/>
-              </a:rPr>
-              <a:t>	</a:t>
-            </a:r>
-            <a:r>
-              <a:rPr sz="2400" kern="0" dirty="0">
-                <a:solidFill>
-                  <a:srgbClr val="434343"/>
-                </a:solidFill>
-                <a:latin typeface="Roboto"/>
-                <a:cs typeface="Roboto"/>
-              </a:rPr>
-              <a:t>Run</a:t>
-            </a:r>
-            <a:r>
-              <a:rPr sz="2400" kern="0" spc="-33" dirty="0">
-                <a:solidFill>
-                  <a:srgbClr val="434343"/>
-                </a:solidFill>
-                <a:latin typeface="Roboto"/>
-                <a:cs typeface="Roboto"/>
-              </a:rPr>
-              <a:t> </a:t>
-            </a:r>
-            <a:r>
-              <a:rPr sz="2400" kern="0" dirty="0">
-                <a:solidFill>
-                  <a:srgbClr val="434343"/>
-                </a:solidFill>
-                <a:latin typeface="Roboto"/>
-                <a:cs typeface="Roboto"/>
-              </a:rPr>
-              <a:t>the</a:t>
-            </a:r>
-            <a:r>
-              <a:rPr sz="2400" kern="0" spc="-33" dirty="0">
-                <a:solidFill>
-                  <a:srgbClr val="434343"/>
-                </a:solidFill>
-                <a:latin typeface="Roboto"/>
-                <a:cs typeface="Roboto"/>
-              </a:rPr>
-              <a:t> </a:t>
-            </a:r>
-            <a:r>
-              <a:rPr sz="2400" kern="0" dirty="0">
-                <a:solidFill>
-                  <a:srgbClr val="434343"/>
-                </a:solidFill>
-                <a:latin typeface="Roboto"/>
-                <a:cs typeface="Roboto"/>
-              </a:rPr>
-              <a:t>following</a:t>
-            </a:r>
-            <a:r>
-              <a:rPr sz="2400" kern="0" spc="-33" dirty="0">
-                <a:solidFill>
-                  <a:srgbClr val="434343"/>
-                </a:solidFill>
-                <a:latin typeface="Roboto"/>
-                <a:cs typeface="Roboto"/>
-              </a:rPr>
-              <a:t> </a:t>
-            </a:r>
-            <a:r>
-              <a:rPr sz="2400" kern="0" spc="-13" dirty="0">
-                <a:solidFill>
-                  <a:srgbClr val="434343"/>
-                </a:solidFill>
-                <a:latin typeface="Roboto"/>
-                <a:cs typeface="Roboto"/>
-              </a:rPr>
-              <a:t>command</a:t>
-            </a:r>
-            <a:endParaRPr sz="2400" kern="0">
-              <a:solidFill>
-                <a:sysClr val="windowText" lastClr="000000"/>
-              </a:solidFill>
-              <a:latin typeface="Roboto"/>
-              <a:cs typeface="Roboto"/>
-            </a:endParaRPr>
-          </a:p>
-          <a:p>
-            <a:pPr marL="16933" defTabSz="1219170">
-              <a:spcBef>
-                <a:spcPts val="1333"/>
-              </a:spcBef>
-            </a:pPr>
-            <a:r>
-              <a:rPr sz="2400" b="1" kern="0" spc="-13" dirty="0">
-                <a:solidFill>
-                  <a:srgbClr val="212D73"/>
-                </a:solidFill>
-                <a:latin typeface="Roboto"/>
-                <a:cs typeface="Roboto"/>
-              </a:rPr>
-              <a:t>hackrf_transfer</a:t>
-            </a:r>
-            <a:r>
-              <a:rPr sz="2400" b="1" kern="0" spc="-40" dirty="0">
-                <a:solidFill>
-                  <a:srgbClr val="212D73"/>
-                </a:solidFill>
-                <a:latin typeface="Roboto"/>
-                <a:cs typeface="Roboto"/>
-              </a:rPr>
-              <a:t> </a:t>
-            </a:r>
-            <a:r>
-              <a:rPr sz="2400" b="1" kern="0" spc="-27" dirty="0">
-                <a:solidFill>
-                  <a:srgbClr val="212D73"/>
-                </a:solidFill>
-                <a:latin typeface="Roboto"/>
-                <a:cs typeface="Roboto"/>
-              </a:rPr>
-              <a:t>-</a:t>
-            </a:r>
-            <a:r>
-              <a:rPr sz="2400" b="1" kern="0" dirty="0">
-                <a:solidFill>
-                  <a:srgbClr val="212D73"/>
-                </a:solidFill>
-                <a:latin typeface="Roboto"/>
-                <a:cs typeface="Roboto"/>
-              </a:rPr>
-              <a:t>p</a:t>
-            </a:r>
-            <a:r>
-              <a:rPr sz="2400" b="1" kern="0" spc="-40" dirty="0">
-                <a:solidFill>
-                  <a:srgbClr val="212D73"/>
-                </a:solidFill>
-                <a:latin typeface="Roboto"/>
-                <a:cs typeface="Roboto"/>
-              </a:rPr>
-              <a:t> </a:t>
-            </a:r>
-            <a:r>
-              <a:rPr sz="2400" b="1" kern="0" dirty="0">
-                <a:solidFill>
-                  <a:srgbClr val="212D73"/>
-                </a:solidFill>
-                <a:latin typeface="Roboto"/>
-                <a:cs typeface="Roboto"/>
-              </a:rPr>
-              <a:t>1</a:t>
-            </a:r>
-            <a:r>
-              <a:rPr sz="2400" b="1" kern="0" spc="-33" dirty="0">
-                <a:solidFill>
-                  <a:srgbClr val="212D73"/>
-                </a:solidFill>
-                <a:latin typeface="Roboto"/>
-                <a:cs typeface="Roboto"/>
-              </a:rPr>
-              <a:t> </a:t>
-            </a:r>
-            <a:r>
-              <a:rPr sz="2400" b="1" kern="0" spc="-27" dirty="0">
-                <a:solidFill>
-                  <a:srgbClr val="212D73"/>
-                </a:solidFill>
-                <a:latin typeface="Roboto"/>
-                <a:cs typeface="Roboto"/>
-              </a:rPr>
-              <a:t>-</a:t>
-            </a:r>
-            <a:r>
-              <a:rPr sz="2400" b="1" kern="0" dirty="0">
-                <a:solidFill>
-                  <a:srgbClr val="212D73"/>
-                </a:solidFill>
-                <a:latin typeface="Roboto"/>
-                <a:cs typeface="Roboto"/>
-              </a:rPr>
-              <a:t>t</a:t>
-            </a:r>
-            <a:r>
-              <a:rPr sz="2400" b="1" kern="0" spc="-40" dirty="0">
-                <a:solidFill>
-                  <a:srgbClr val="212D73"/>
-                </a:solidFill>
-                <a:latin typeface="Roboto"/>
-                <a:cs typeface="Roboto"/>
-              </a:rPr>
-              <a:t> </a:t>
-            </a:r>
-            <a:r>
-              <a:rPr sz="2400" b="1" kern="0" spc="-13" dirty="0">
-                <a:solidFill>
-                  <a:srgbClr val="212D73"/>
-                </a:solidFill>
-                <a:latin typeface="Roboto"/>
-                <a:cs typeface="Roboto"/>
-              </a:rPr>
-              <a:t>gpssim.bin</a:t>
-            </a:r>
-            <a:r>
-              <a:rPr sz="2400" b="1" kern="0" spc="-33" dirty="0">
-                <a:solidFill>
-                  <a:srgbClr val="212D73"/>
-                </a:solidFill>
-                <a:latin typeface="Roboto"/>
-                <a:cs typeface="Roboto"/>
-              </a:rPr>
-              <a:t> </a:t>
-            </a:r>
-            <a:r>
-              <a:rPr sz="2400" b="1" kern="0" spc="-27" dirty="0">
-                <a:solidFill>
-                  <a:srgbClr val="212D73"/>
-                </a:solidFill>
-                <a:latin typeface="Roboto"/>
-                <a:cs typeface="Roboto"/>
-              </a:rPr>
-              <a:t>-</a:t>
-            </a:r>
-            <a:r>
-              <a:rPr sz="2400" b="1" kern="0" dirty="0">
-                <a:solidFill>
-                  <a:srgbClr val="212D73"/>
-                </a:solidFill>
-                <a:latin typeface="Roboto"/>
-                <a:cs typeface="Roboto"/>
-              </a:rPr>
-              <a:t>f</a:t>
-            </a:r>
-            <a:r>
-              <a:rPr sz="2400" b="1" kern="0" spc="-40" dirty="0">
-                <a:solidFill>
-                  <a:srgbClr val="212D73"/>
-                </a:solidFill>
-                <a:latin typeface="Roboto"/>
-                <a:cs typeface="Roboto"/>
-              </a:rPr>
-              <a:t> </a:t>
-            </a:r>
-            <a:r>
-              <a:rPr sz="2400" b="1" kern="0" spc="-13" dirty="0">
-                <a:solidFill>
-                  <a:srgbClr val="212D73"/>
-                </a:solidFill>
-                <a:latin typeface="Roboto"/>
-                <a:cs typeface="Roboto"/>
-              </a:rPr>
-              <a:t>1575420000</a:t>
-            </a:r>
-            <a:r>
-              <a:rPr sz="2400" b="1" kern="0" spc="-33" dirty="0">
-                <a:solidFill>
-                  <a:srgbClr val="212D73"/>
-                </a:solidFill>
-                <a:latin typeface="Roboto"/>
-                <a:cs typeface="Roboto"/>
-              </a:rPr>
-              <a:t> </a:t>
-            </a:r>
-            <a:r>
-              <a:rPr sz="2400" b="1" kern="0" spc="-27" dirty="0">
-                <a:solidFill>
-                  <a:srgbClr val="212D73"/>
-                </a:solidFill>
-                <a:latin typeface="Roboto"/>
-                <a:cs typeface="Roboto"/>
-              </a:rPr>
-              <a:t>-</a:t>
-            </a:r>
-            <a:r>
-              <a:rPr sz="2400" b="1" kern="0" dirty="0">
-                <a:solidFill>
-                  <a:srgbClr val="212D73"/>
-                </a:solidFill>
-                <a:latin typeface="Roboto"/>
-                <a:cs typeface="Roboto"/>
-              </a:rPr>
-              <a:t>s</a:t>
-            </a:r>
-            <a:r>
-              <a:rPr sz="2400" b="1" kern="0" spc="-40" dirty="0">
-                <a:solidFill>
-                  <a:srgbClr val="212D73"/>
-                </a:solidFill>
-                <a:latin typeface="Roboto"/>
-                <a:cs typeface="Roboto"/>
-              </a:rPr>
-              <a:t> </a:t>
-            </a:r>
-            <a:r>
-              <a:rPr sz="2400" b="1" kern="0" dirty="0">
-                <a:solidFill>
-                  <a:srgbClr val="212D73"/>
-                </a:solidFill>
-                <a:latin typeface="Roboto"/>
-                <a:cs typeface="Roboto"/>
-              </a:rPr>
-              <a:t>2600000</a:t>
-            </a:r>
-            <a:r>
-              <a:rPr sz="2400" b="1" kern="0" spc="-33" dirty="0">
-                <a:solidFill>
-                  <a:srgbClr val="212D73"/>
-                </a:solidFill>
-                <a:latin typeface="Roboto"/>
-                <a:cs typeface="Roboto"/>
-              </a:rPr>
-              <a:t> </a:t>
-            </a:r>
-            <a:r>
-              <a:rPr sz="2400" b="1" kern="0" spc="-13" dirty="0">
-                <a:solidFill>
-                  <a:srgbClr val="212D73"/>
-                </a:solidFill>
-                <a:latin typeface="Roboto"/>
-                <a:cs typeface="Roboto"/>
-              </a:rPr>
-              <a:t>-</a:t>
-            </a:r>
-            <a:r>
-              <a:rPr sz="2400" b="1" kern="0" dirty="0">
-                <a:solidFill>
-                  <a:srgbClr val="212D73"/>
-                </a:solidFill>
-                <a:latin typeface="Roboto"/>
-                <a:cs typeface="Roboto"/>
-              </a:rPr>
-              <a:t>a</a:t>
-            </a:r>
-            <a:r>
-              <a:rPr sz="2400" b="1" kern="0" spc="-40" dirty="0">
-                <a:solidFill>
-                  <a:srgbClr val="212D73"/>
-                </a:solidFill>
-                <a:latin typeface="Roboto"/>
-                <a:cs typeface="Roboto"/>
-              </a:rPr>
-              <a:t> </a:t>
-            </a:r>
-            <a:r>
-              <a:rPr sz="2400" b="1" kern="0" dirty="0">
-                <a:solidFill>
-                  <a:srgbClr val="212D73"/>
-                </a:solidFill>
-                <a:latin typeface="Roboto"/>
-                <a:cs typeface="Roboto"/>
-              </a:rPr>
-              <a:t>1</a:t>
-            </a:r>
-            <a:r>
-              <a:rPr sz="2400" b="1" kern="0" spc="-33" dirty="0">
-                <a:solidFill>
-                  <a:srgbClr val="212D73"/>
-                </a:solidFill>
-                <a:latin typeface="Roboto"/>
-                <a:cs typeface="Roboto"/>
-              </a:rPr>
-              <a:t> </a:t>
-            </a:r>
-            <a:r>
-              <a:rPr sz="2400" b="1" kern="0" spc="-13" dirty="0">
-                <a:solidFill>
-                  <a:srgbClr val="212D73"/>
-                </a:solidFill>
-                <a:latin typeface="Roboto"/>
-                <a:cs typeface="Roboto"/>
-              </a:rPr>
-              <a:t>-</a:t>
-            </a:r>
-            <a:r>
-              <a:rPr sz="2400" b="1" kern="0" dirty="0">
-                <a:solidFill>
-                  <a:srgbClr val="212D73"/>
-                </a:solidFill>
-                <a:latin typeface="Roboto"/>
-                <a:cs typeface="Roboto"/>
-              </a:rPr>
-              <a:t>x</a:t>
-            </a:r>
-            <a:r>
-              <a:rPr sz="2400" b="1" kern="0" spc="-40" dirty="0">
-                <a:solidFill>
-                  <a:srgbClr val="212D73"/>
-                </a:solidFill>
-                <a:latin typeface="Roboto"/>
-                <a:cs typeface="Roboto"/>
-              </a:rPr>
-              <a:t> </a:t>
-            </a:r>
-            <a:r>
-              <a:rPr sz="2400" b="1" kern="0" spc="-33" dirty="0">
-                <a:solidFill>
-                  <a:srgbClr val="212D73"/>
-                </a:solidFill>
-                <a:latin typeface="Roboto"/>
-                <a:cs typeface="Roboto"/>
-              </a:rPr>
-              <a:t>30</a:t>
-            </a:r>
-            <a:endParaRPr sz="2400" kern="0">
-              <a:solidFill>
-                <a:sysClr val="windowText" lastClr="000000"/>
-              </a:solidFill>
-              <a:latin typeface="Roboto"/>
-              <a:cs typeface="Roboto"/>
-            </a:endParaRPr>
-          </a:p>
-        </p:txBody>
-      </p:sp>
-      <p:pic>
-        <p:nvPicPr>
-          <p:cNvPr id="4" name="object 4"/>
-          <p:cNvPicPr/>
-          <p:nvPr/>
-        </p:nvPicPr>
-        <p:blipFill>
-          <a:blip r:embed="rId3" cstate="print"/>
-          <a:stretch>
-            <a:fillRect/>
-          </a:stretch>
-        </p:blipFill>
-        <p:spPr>
-          <a:xfrm>
-            <a:off x="2617465" y="3048466"/>
-            <a:ext cx="7281865" cy="3558065"/>
-          </a:xfrm>
-          <a:prstGeom prst="rect">
-            <a:avLst/>
-          </a:prstGeom>
-        </p:spPr>
-      </p:pic>
-    </p:spTree>
-    <p:custDataLst>
-      <p:tags r:id="rId1"/>
-    </p:custDataLst>
-  </p:cSld>
-  <p:clrMapOvr>
-    <a:masterClrMapping/>
-  </p:clrMapOvr>
-</p:sld>
-</file>
-
-<file path=ppt/slides/slide9.xml><?xml version="1.0" encoding="utf-8"?>
 <p:sld xmlns:a="http://schemas.openxmlformats.org/drawingml/2006/main" xmlns:r="http://schemas.openxmlformats.org/officeDocument/2006/relationships" xmlns:p="http://schemas.openxmlformats.org/presentationml/2006/main">
   <p:cSld>
     <p:spTree>
@@ -11327,6 +8021,253 @@
 </p:sld>
 </file>
 
+<file path=ppt/slides/slide8.xml><?xml version="1.0" encoding="utf-8"?>
+<p:sld xmlns:a="http://schemas.openxmlformats.org/drawingml/2006/main" xmlns:r="http://schemas.openxmlformats.org/officeDocument/2006/relationships" xmlns:p="http://schemas.openxmlformats.org/presentationml/2006/main">
+  <p:cSld>
+    <p:spTree>
+      <p:nvGrpSpPr>
+        <p:cNvPr id="1" name=""/>
+        <p:cNvGrpSpPr/>
+        <p:nvPr/>
+      </p:nvGrpSpPr>
+      <p:grpSpPr>
+        <a:xfrm>
+          <a:off x="0" y="0"/>
+          <a:ext cx="0" cy="0"/>
+          <a:chOff x="0" y="0"/>
+          <a:chExt cx="0" cy="0"/>
+        </a:xfrm>
+      </p:grpSpPr>
+      <p:sp>
+        <p:nvSpPr>
+          <p:cNvPr id="10245" name="Title 1"/>
+          <p:cNvSpPr>
+            <a:spLocks noGrp="1"/>
+          </p:cNvSpPr>
+          <p:nvPr>
+            <p:ph type="title"/>
+          </p:nvPr>
+        </p:nvSpPr>
+        <p:spPr>
+          <a:xfrm>
+            <a:off x="1981200" y="274638"/>
+            <a:ext cx="8229600" cy="698305"/>
+          </a:xfrm>
+        </p:spPr>
+        <p:txBody>
+          <a:bodyPr>
+            <a:normAutofit fontScale="90000"/>
+          </a:bodyPr>
+          <a:lstStyle/>
+          <a:p>
+            <a:r>
+              <a:rPr lang="en-US" dirty="0"/>
+              <a:t>GPS Security</a:t>
+            </a:r>
+          </a:p>
+        </p:txBody>
+      </p:sp>
+      <p:sp>
+        <p:nvSpPr>
+          <p:cNvPr id="17411" name="Content Placeholder 10"/>
+          <p:cNvSpPr>
+            <a:spLocks noGrp="1"/>
+          </p:cNvSpPr>
+          <p:nvPr>
+            <p:ph idx="1"/>
+          </p:nvPr>
+        </p:nvSpPr>
+        <p:spPr>
+          <a:xfrm>
+            <a:off x="1792288" y="972943"/>
+            <a:ext cx="8699500" cy="5451671"/>
+          </a:xfrm>
+        </p:spPr>
+        <p:txBody>
+          <a:bodyPr>
+            <a:normAutofit/>
+          </a:bodyPr>
+          <a:lstStyle/>
+          <a:p>
+            <a:r>
+              <a:rPr lang="en-US" sz="1600" dirty="0"/>
+              <a:t>Interference</a:t>
+            </a:r>
+          </a:p>
+          <a:p>
+            <a:pPr lvl="1"/>
+            <a:r>
+              <a:rPr lang="en-US" sz="1200" dirty="0"/>
+              <a:t>Typically environmental</a:t>
+            </a:r>
+          </a:p>
+          <a:p>
+            <a:pPr lvl="1"/>
+            <a:r>
+              <a:rPr lang="en-US" sz="1200" dirty="0">
+                <a:hlinkClick r:id="rId3"/>
+              </a:rPr>
+              <a:t>https://www.gps.gov/spectrum/</a:t>
+            </a:r>
+            <a:endParaRPr lang="en-US" sz="1200" dirty="0"/>
+          </a:p>
+          <a:p>
+            <a:pPr lvl="1"/>
+            <a:r>
+              <a:rPr lang="en-US" sz="1200" dirty="0">
+                <a:hlinkClick r:id="rId4"/>
+              </a:rPr>
+              <a:t>https://www.gps.gov/news/2012/03/solarstorm/</a:t>
+            </a:r>
+            <a:endParaRPr lang="en-US" sz="1200" dirty="0"/>
+          </a:p>
+          <a:p>
+            <a:r>
+              <a:rPr lang="en-US" sz="1600" dirty="0"/>
+              <a:t>Jamming</a:t>
+            </a:r>
+          </a:p>
+          <a:p>
+            <a:pPr lvl="1"/>
+            <a:r>
+              <a:rPr lang="en-US" sz="1200" dirty="0"/>
+              <a:t>Is illegal</a:t>
+            </a:r>
+          </a:p>
+          <a:p>
+            <a:pPr lvl="1"/>
+            <a:r>
+              <a:rPr lang="en-US" sz="1200" dirty="0">
+                <a:hlinkClick r:id="rId5"/>
+              </a:rPr>
+              <a:t>https://www.gps.gov/spectrum/jamming/</a:t>
+            </a:r>
+          </a:p>
+          <a:p>
+            <a:pPr lvl="1"/>
+            <a:r>
+              <a:rPr lang="en-US" sz="1200" dirty="0">
+                <a:hlinkClick r:id="rId5"/>
+              </a:rPr>
+              <a:t>http://gpsworld.com/tag/gps-jamming/</a:t>
+            </a:r>
+          </a:p>
+          <a:p>
+            <a:pPr lvl="1"/>
+            <a:r>
+              <a:rPr lang="en-US" sz="1200" dirty="0">
+                <a:hlinkClick r:id="rId5"/>
+              </a:rPr>
+              <a:t>https://www.thesignaljammer.com/pages/How-GPS-Jammers-Work.html</a:t>
+            </a:r>
+            <a:endParaRPr lang="en-US" sz="1200" dirty="0"/>
+          </a:p>
+          <a:p>
+            <a:pPr lvl="1"/>
+            <a:r>
+              <a:rPr lang="en-US" sz="1200" dirty="0">
+                <a:hlinkClick r:id="rId6"/>
+              </a:rPr>
+              <a:t>https://gizmodo.com/jamming-gps-signals-is-illegal-dangerous-cheap-and-e-1796778955</a:t>
+            </a:r>
+            <a:endParaRPr lang="en-US" sz="1200" dirty="0"/>
+          </a:p>
+          <a:p>
+            <a:r>
+              <a:rPr lang="en-US" sz="1600" dirty="0"/>
+              <a:t>Spoofing (broadcasting false information)</a:t>
+            </a:r>
+          </a:p>
+          <a:p>
+            <a:pPr lvl="1"/>
+            <a:r>
+              <a:rPr lang="en-US" sz="1200" dirty="0"/>
+              <a:t>Is also illegal</a:t>
+            </a:r>
+            <a:endParaRPr lang="en-US" sz="1200" dirty="0">
+              <a:hlinkClick r:id="rId7"/>
+            </a:endParaRPr>
+          </a:p>
+          <a:p>
+            <a:pPr lvl="1"/>
+            <a:r>
+              <a:rPr lang="en-US" sz="1200" dirty="0">
+                <a:hlinkClick r:id="rId7"/>
+              </a:rPr>
+              <a:t>https://www.gps.gov/multimedia/presentations/2016/04/APEC/alexander-2.pdf</a:t>
+            </a:r>
+          </a:p>
+          <a:p>
+            <a:pPr lvl="1"/>
+            <a:r>
+              <a:rPr lang="en-US" sz="1200" dirty="0">
+                <a:hlinkClick r:id="rId7"/>
+              </a:rPr>
+              <a:t>https://en.wikipedia.org/wiki/Spoofing_attack#GPS_spoofing</a:t>
+            </a:r>
+          </a:p>
+          <a:p>
+            <a:pPr lvl="1"/>
+            <a:r>
+              <a:rPr lang="en-US" sz="1200" dirty="0">
+                <a:hlinkClick r:id="rId7"/>
+              </a:rPr>
+              <a:t>https://www.schneier.com/blog/archives/2017/09/gps_spoofing_at.html</a:t>
+            </a:r>
+          </a:p>
+          <a:p>
+            <a:pPr lvl="1"/>
+            <a:r>
+              <a:rPr lang="en-US" sz="1200" dirty="0">
+                <a:hlinkClick r:id="rId7"/>
+              </a:rPr>
+              <a:t>https://www.spirent.com/Blogs/Positioning/2015/September/GPS_Spoofing_Is_a_Real_Threat</a:t>
+            </a:r>
+          </a:p>
+          <a:p>
+            <a:pPr lvl="1"/>
+            <a:r>
+              <a:rPr lang="en-US" sz="1200" dirty="0">
+                <a:hlinkClick r:id="rId7"/>
+              </a:rPr>
+              <a:t>https://www.spirent.com/Blogs/Positioning/2017/September/DEFCON-25</a:t>
+            </a:r>
+          </a:p>
+          <a:p>
+            <a:pPr lvl="1"/>
+            <a:r>
+              <a:rPr lang="en-US" sz="1200" dirty="0">
+                <a:hlinkClick r:id="rId7"/>
+              </a:rPr>
+              <a:t>https://www.digitaltrends.com/mobile/gps-spoofing/</a:t>
+            </a:r>
+            <a:endParaRPr lang="en-US" sz="1200" dirty="0"/>
+          </a:p>
+          <a:p>
+            <a:pPr lvl="1"/>
+            <a:endParaRPr lang="en-US" sz="1200" dirty="0"/>
+          </a:p>
+          <a:p>
+            <a:endParaRPr lang="en-US" sz="1400" dirty="0"/>
+          </a:p>
+        </p:txBody>
+      </p:sp>
+    </p:spTree>
+    <p:extLst>
+      <p:ext uri="{BB962C8B-B14F-4D97-AF65-F5344CB8AC3E}">
+        <p14:creationId xmlns:p14="http://schemas.microsoft.com/office/powerpoint/2010/main" val="2741046450"/>
+      </p:ext>
+    </p:extLst>
+  </p:cSld>
+  <p:clrMapOvr>
+    <a:masterClrMapping/>
+  </p:clrMapOvr>
+  <p:transition>
+    <p:fade/>
+  </p:transition>
+</p:sld>
+</file>
+
 <file path=ppt/tags/tag1.xml><?xml version="1.0" encoding="utf-8"?>
 <p:tagLst xmlns:a="http://schemas.openxmlformats.org/drawingml/2006/main" xmlns:r="http://schemas.openxmlformats.org/officeDocument/2006/relationships" xmlns:p="http://schemas.openxmlformats.org/presentationml/2006/main">
   <p:tag name="ARTICULATE_PROJECT_OPEN" val="0"/>
@@ -11347,30 +8288,6 @@
 </file>
 
 <file path=ppt/tags/tag4.xml><?xml version="1.0" encoding="utf-8"?>
-<p:tagLst xmlns:a="http://schemas.openxmlformats.org/drawingml/2006/main" xmlns:r="http://schemas.openxmlformats.org/officeDocument/2006/relationships" xmlns:p="http://schemas.openxmlformats.org/presentationml/2006/main">
-  <p:tag name="ARTICULATE_SLIDE_THUMBNAIL_REFRESH" val="1"/>
-</p:tagLst>
-</file>
-
-<file path=ppt/tags/tag5.xml><?xml version="1.0" encoding="utf-8"?>
-<p:tagLst xmlns:a="http://schemas.openxmlformats.org/drawingml/2006/main" xmlns:r="http://schemas.openxmlformats.org/officeDocument/2006/relationships" xmlns:p="http://schemas.openxmlformats.org/presentationml/2006/main">
-  <p:tag name="ARTICULATE_SLIDE_THUMBNAIL_REFRESH" val="1"/>
-</p:tagLst>
-</file>
-
-<file path=ppt/tags/tag6.xml><?xml version="1.0" encoding="utf-8"?>
-<p:tagLst xmlns:a="http://schemas.openxmlformats.org/drawingml/2006/main" xmlns:r="http://schemas.openxmlformats.org/officeDocument/2006/relationships" xmlns:p="http://schemas.openxmlformats.org/presentationml/2006/main">
-  <p:tag name="ARTICULATE_SLIDE_THUMBNAIL_REFRESH" val="1"/>
-</p:tagLst>
-</file>
-
-<file path=ppt/tags/tag7.xml><?xml version="1.0" encoding="utf-8"?>
-<p:tagLst xmlns:a="http://schemas.openxmlformats.org/drawingml/2006/main" xmlns:r="http://schemas.openxmlformats.org/officeDocument/2006/relationships" xmlns:p="http://schemas.openxmlformats.org/presentationml/2006/main">
-  <p:tag name="ARTICULATE_SLIDE_THUMBNAIL_REFRESH" val="1"/>
-</p:tagLst>
-</file>
-
-<file path=ppt/tags/tag8.xml><?xml version="1.0" encoding="utf-8"?>
 <p:tagLst xmlns:a="http://schemas.openxmlformats.org/drawingml/2006/main" xmlns:r="http://schemas.openxmlformats.org/officeDocument/2006/relationships" xmlns:p="http://schemas.openxmlformats.org/presentationml/2006/main">
   <p:tag name="ARTICULATE_SLIDE_THUMBNAIL_REFRESH" val="1"/>
 </p:tagLst>
@@ -12007,22 +8924,65 @@
 </file>
 
 <file path=customXml/item1.xml><?xml version="1.0" encoding="utf-8"?>
-<p:properties xmlns:p="http://schemas.microsoft.com/office/2006/metadata/properties" xmlns:xsi="http://www.w3.org/2001/XMLSchema-instance" xmlns:pc="http://schemas.microsoft.com/office/infopath/2007/PartnerControls">
-  <documentManagement>
-    <_dlc_DocId xmlns="c7a77415-c4a3-4262-8430-671f3e8707b6">7J4PPY27XH2W-901365475-257158</_dlc_DocId>
-    <_dlc_DocIdUrl xmlns="c7a77415-c4a3-4262-8430-671f3e8707b6">
-      <Url>https://automotivei.sharepoint.com/sites/PMO/_layouts/15/DocIdRedir.aspx?ID=7J4PPY27XH2W-901365475-257158</Url>
-      <Description>7J4PPY27XH2W-901365475-257158</Description>
-    </_dlc_DocIdUrl>
-    <TaxCatchAll xmlns="c7a77415-c4a3-4262-8430-671f3e8707b6" xsi:nil="true"/>
-    <lcf76f155ced4ddcb4097134ff3c332f xmlns="69a7259e-7a2c-42d5-bc84-25eccf0dce8b">
-      <Terms xmlns="http://schemas.microsoft.com/office/infopath/2007/PartnerControls"/>
-    </lcf76f155ced4ddcb4097134ff3c332f>
-  </documentManagement>
-</p:properties>
+<?mso-contentType ?>
+<spe:Receivers xmlns:spe="http://schemas.microsoft.com/sharepoint/events">
+  <Receiver>
+    <Name>Document ID Generator</Name>
+    <Synchronization>Synchronous</Synchronization>
+    <Type>10001</Type>
+    <SequenceNumber>1000</SequenceNumber>
+    <Url/>
+    <Assembly>Microsoft.Office.DocumentManagement, Version=16.0.0.0, Culture=neutral, PublicKeyToken=71e9bce111e9429c</Assembly>
+    <Class>Microsoft.Office.DocumentManagement.Internal.DocIdHandler</Class>
+    <Data/>
+    <Filter/>
+  </Receiver>
+  <Receiver>
+    <Name>Document ID Generator</Name>
+    <Synchronization>Synchronous</Synchronization>
+    <Type>10002</Type>
+    <SequenceNumber>1001</SequenceNumber>
+    <Url/>
+    <Assembly>Microsoft.Office.DocumentManagement, Version=16.0.0.0, Culture=neutral, PublicKeyToken=71e9bce111e9429c</Assembly>
+    <Class>Microsoft.Office.DocumentManagement.Internal.DocIdHandler</Class>
+    <Data/>
+    <Filter/>
+  </Receiver>
+  <Receiver>
+    <Name>Document ID Generator</Name>
+    <Synchronization>Synchronous</Synchronization>
+    <Type>10004</Type>
+    <SequenceNumber>1002</SequenceNumber>
+    <Url/>
+    <Assembly>Microsoft.Office.DocumentManagement, Version=16.0.0.0, Culture=neutral, PublicKeyToken=71e9bce111e9429c</Assembly>
+    <Class>Microsoft.Office.DocumentManagement.Internal.DocIdHandler</Class>
+    <Data/>
+    <Filter/>
+  </Receiver>
+  <Receiver>
+    <Name>Document ID Generator</Name>
+    <Synchronization>Synchronous</Synchronization>
+    <Type>10006</Type>
+    <SequenceNumber>1003</SequenceNumber>
+    <Url/>
+    <Assembly>Microsoft.Office.DocumentManagement, Version=16.0.0.0, Culture=neutral, PublicKeyToken=71e9bce111e9429c</Assembly>
+    <Class>Microsoft.Office.DocumentManagement.Internal.DocIdHandler</Class>
+    <Data/>
+    <Filter/>
+  </Receiver>
+</spe:Receivers>
 </file>
 
 <file path=customXml/item2.xml><?xml version="1.0" encoding="utf-8"?>
+<?mso-contentType ?>
+<FormTemplates xmlns="http://schemas.microsoft.com/sharepoint/v3/contenttype/forms">
+  <Display>DocumentLibraryForm</Display>
+  <Edit>DocumentLibraryForm</Edit>
+  <New>DocumentLibraryForm</New>
+</FormTemplates>
+</file>
+
+<file path=customXml/item3.xml><?xml version="1.0" encoding="utf-8"?>
 <ct:contentTypeSchema xmlns:ct="http://schemas.microsoft.com/office/2006/metadata/contentType" xmlns:ma="http://schemas.microsoft.com/office/2006/metadata/properties/metaAttributes" ct:_="" ma:_="" ma:contentTypeName="Document" ma:contentTypeID="0x01010067B86F8708159745A0B6896184DE9576" ma:contentTypeVersion="19" ma:contentTypeDescription="Create a new document." ma:contentTypeScope="" ma:versionID="493bf26d373952ea1ae3b9e24cd19b33">
   <xsd:schema xmlns:xsd="http://www.w3.org/2001/XMLSchema" xmlns:xs="http://www.w3.org/2001/XMLSchema" xmlns:p="http://schemas.microsoft.com/office/2006/metadata/properties" xmlns:ns2="c7a77415-c4a3-4262-8430-671f3e8707b6" xmlns:ns3="69a7259e-7a2c-42d5-bc84-25eccf0dce8b" targetNamespace="http://schemas.microsoft.com/office/2006/metadata/properties" ma:root="true" ma:fieldsID="69c00e31f84d56e19bb090b7ea67ab52" ns2:_="" ns3:_="">
     <xsd:import namespace="c7a77415-c4a3-4262-8430-671f3e8707b6"/>
@@ -12308,77 +9268,39 @@
 </ct:contentTypeSchema>
 </file>
 
-<file path=customXml/item3.xml><?xml version="1.0" encoding="utf-8"?>
-<?mso-contentType ?>
-<FormTemplates xmlns="http://schemas.microsoft.com/sharepoint/v3/contenttype/forms">
-  <Display>DocumentLibraryForm</Display>
-  <Edit>DocumentLibraryForm</Edit>
-  <New>DocumentLibraryForm</New>
-</FormTemplates>
-</file>
-
 <file path=customXml/item4.xml><?xml version="1.0" encoding="utf-8"?>
-<?mso-contentType ?>
-<spe:Receivers xmlns:spe="http://schemas.microsoft.com/sharepoint/events">
-  <Receiver>
-    <Name>Document ID Generator</Name>
-    <Synchronization>Synchronous</Synchronization>
-    <Type>10001</Type>
-    <SequenceNumber>1000</SequenceNumber>
-    <Url/>
-    <Assembly>Microsoft.Office.DocumentManagement, Version=16.0.0.0, Culture=neutral, PublicKeyToken=71e9bce111e9429c</Assembly>
-    <Class>Microsoft.Office.DocumentManagement.Internal.DocIdHandler</Class>
-    <Data/>
-    <Filter/>
-  </Receiver>
-  <Receiver>
-    <Name>Document ID Generator</Name>
-    <Synchronization>Synchronous</Synchronization>
-    <Type>10002</Type>
-    <SequenceNumber>1001</SequenceNumber>
-    <Url/>
-    <Assembly>Microsoft.Office.DocumentManagement, Version=16.0.0.0, Culture=neutral, PublicKeyToken=71e9bce111e9429c</Assembly>
-    <Class>Microsoft.Office.DocumentManagement.Internal.DocIdHandler</Class>
-    <Data/>
-    <Filter/>
-  </Receiver>
-  <Receiver>
-    <Name>Document ID Generator</Name>
-    <Synchronization>Synchronous</Synchronization>
-    <Type>10004</Type>
-    <SequenceNumber>1002</SequenceNumber>
-    <Url/>
-    <Assembly>Microsoft.Office.DocumentManagement, Version=16.0.0.0, Culture=neutral, PublicKeyToken=71e9bce111e9429c</Assembly>
-    <Class>Microsoft.Office.DocumentManagement.Internal.DocIdHandler</Class>
-    <Data/>
-    <Filter/>
-  </Receiver>
-  <Receiver>
-    <Name>Document ID Generator</Name>
-    <Synchronization>Synchronous</Synchronization>
-    <Type>10006</Type>
-    <SequenceNumber>1003</SequenceNumber>
-    <Url/>
-    <Assembly>Microsoft.Office.DocumentManagement, Version=16.0.0.0, Culture=neutral, PublicKeyToken=71e9bce111e9429c</Assembly>
-    <Class>Microsoft.Office.DocumentManagement.Internal.DocIdHandler</Class>
-    <Data/>
-    <Filter/>
-  </Receiver>
-</spe:Receivers>
+<p:properties xmlns:p="http://schemas.microsoft.com/office/2006/metadata/properties" xmlns:xsi="http://www.w3.org/2001/XMLSchema-instance" xmlns:pc="http://schemas.microsoft.com/office/infopath/2007/PartnerControls">
+  <documentManagement>
+    <_dlc_DocId xmlns="c7a77415-c4a3-4262-8430-671f3e8707b6">7J4PPY27XH2W-901365475-257158</_dlc_DocId>
+    <_dlc_DocIdUrl xmlns="c7a77415-c4a3-4262-8430-671f3e8707b6">
+      <Url>https://automotivei.sharepoint.com/sites/PMO/_layouts/15/DocIdRedir.aspx?ID=7J4PPY27XH2W-901365475-257158</Url>
+      <Description>7J4PPY27XH2W-901365475-257158</Description>
+    </_dlc_DocIdUrl>
+    <TaxCatchAll xmlns="c7a77415-c4a3-4262-8430-671f3e8707b6" xsi:nil="true"/>
+    <lcf76f155ced4ddcb4097134ff3c332f xmlns="69a7259e-7a2c-42d5-bc84-25eccf0dce8b">
+      <Terms xmlns="http://schemas.microsoft.com/office/infopath/2007/PartnerControls"/>
+    </lcf76f155ced4ddcb4097134ff3c332f>
+  </documentManagement>
+</p:properties>
 </file>
 
 <file path=customXml/itemProps1.xml><?xml version="1.0" encoding="utf-8"?>
-<ds:datastoreItem xmlns:ds="http://schemas.openxmlformats.org/officeDocument/2006/customXml" ds:itemID="{E71A463F-9F4B-47AC-91AA-3962FD8F3CE5}">
+<ds:datastoreItem xmlns:ds="http://schemas.openxmlformats.org/officeDocument/2006/customXml" ds:itemID="{54C592EF-85C1-482B-896B-DED434B6FCCC}">
   <ds:schemaRefs>
-    <ds:schemaRef ds:uri="http://schemas.microsoft.com/office/2006/metadata/properties"/>
-    <ds:schemaRef ds:uri="http://schemas.microsoft.com/office/infopath/2007/PartnerControls"/>
-    <ds:schemaRef ds:uri="c7a77415-c4a3-4262-8430-671f3e8707b6"/>
-    <ds:schemaRef ds:uri="69a7259e-7a2c-42d5-bc84-25eccf0dce8b"/>
+    <ds:schemaRef ds:uri="http://schemas.microsoft.com/sharepoint/events"/>
   </ds:schemaRefs>
 </ds:datastoreItem>
 </file>
 
 <file path=customXml/itemProps2.xml><?xml version="1.0" encoding="utf-8"?>
+<ds:datastoreItem xmlns:ds="http://schemas.openxmlformats.org/officeDocument/2006/customXml" ds:itemID="{84EE72F3-C956-4A5B-833F-E761B5D8ACD8}">
+  <ds:schemaRefs>
+    <ds:schemaRef ds:uri="http://schemas.microsoft.com/sharepoint/v3/contenttype/forms"/>
+  </ds:schemaRefs>
+</ds:datastoreItem>
+</file>
+
+<file path=customXml/itemProps3.xml><?xml version="1.0" encoding="utf-8"?>
 <ds:datastoreItem xmlns:ds="http://schemas.openxmlformats.org/officeDocument/2006/customXml" ds:itemID="{8FEF19B7-7529-453B-A7D5-A8465340F17A}">
   <ds:schemaRefs>
     <ds:schemaRef ds:uri="http://schemas.microsoft.com/office/2006/metadata/contentType"/>
@@ -12397,18 +9319,13 @@
 </ds:datastoreItem>
 </file>
 
-<file path=customXml/itemProps3.xml><?xml version="1.0" encoding="utf-8"?>
-<ds:datastoreItem xmlns:ds="http://schemas.openxmlformats.org/officeDocument/2006/customXml" ds:itemID="{84EE72F3-C956-4A5B-833F-E761B5D8ACD8}">
+<file path=customXml/itemProps4.xml><?xml version="1.0" encoding="utf-8"?>
+<ds:datastoreItem xmlns:ds="http://schemas.openxmlformats.org/officeDocument/2006/customXml" ds:itemID="{E71A463F-9F4B-47AC-91AA-3962FD8F3CE5}">
   <ds:schemaRefs>
-    <ds:schemaRef ds:uri="http://schemas.microsoft.com/sharepoint/v3/contenttype/forms"/>
-  </ds:schemaRefs>
-</ds:datastoreItem>
-</file>
-
-<file path=customXml/itemProps4.xml><?xml version="1.0" encoding="utf-8"?>
-<ds:datastoreItem xmlns:ds="http://schemas.openxmlformats.org/officeDocument/2006/customXml" ds:itemID="{54C592EF-85C1-482B-896B-DED434B6FCCC}">
-  <ds:schemaRefs>
-    <ds:schemaRef ds:uri="http://schemas.microsoft.com/sharepoint/events"/>
+    <ds:schemaRef ds:uri="http://schemas.microsoft.com/office/2006/metadata/properties"/>
+    <ds:schemaRef ds:uri="http://schemas.microsoft.com/office/infopath/2007/PartnerControls"/>
+    <ds:schemaRef ds:uri="c7a77415-c4a3-4262-8430-671f3e8707b6"/>
+    <ds:schemaRef ds:uri="69a7259e-7a2c-42d5-bc84-25eccf0dce8b"/>
   </ds:schemaRefs>
 </ds:datastoreItem>
 </file>
</xml_diff>